<commit_message>
The three architecture slides are the picture: diagrams trimmed of their page padding and drawn as large as the slide allows, their bullets moved to the notes
Co-Authored-By: Claude Fable 5 <noreply@anthropic.com>
</commit_message>
<xml_diff>
--- a/docs/deck/aoi-agent-journey.zh-TW.pptx
+++ b/docs/deck/aoi-agent-journey.zh-TW.pptx
@@ -3890,6 +3890,37 @@
           <a:p/>
           <a:p>
             <a:r>
+              <a:t>頁面上只有圖；要點：</a:t>
+            </a:r>
+          </a:p>
+          <a:p>
+            <a:r>
+              <a:t>• 相減前端：樣板減待測，產生候選（也就是「AOI」）</a:t>
+            </a:r>
+          </a:p>
+          <a:p>
+            <a:r>
+              <a:t>• 複判模型：ResNet-18 看每個候選，給 P(false call) 和六類機率</a:t>
+            </a:r>
+          </a:p>
+          <a:p>
+            <a:r>
+              <a:t>• 門檻與路由：兩個數字決定誰直接處置、誰交給人</a:t>
+            </a:r>
+          </a:p>
+          <a:p>
+            <a:r>
+              <a:t>• Agent 與站台：LLM 寫說明、人做判定、每個判定記名字和模型版本</a:t>
+            </a:r>
+          </a:p>
+          <a:p>
+            <a:r>
+              <a:t>• /ask：主管問一句話，系統規劃查詢、驗證、查完畫圖寫答案</a:t>
+            </a:r>
+          </a:p>
+          <a:p/>
+          <a:p>
+            <a:r>
               <a:t>講稿 1. 五層，由左往右。前兩層是視覺，中間是兩個門檻，後兩層是語言模型和人。</a:t>
             </a:r>
           </a:p>
@@ -4008,6 +4039,27 @@
           <a:p/>
           <a:p>
             <a:r>
+              <a:t>頁面上只有圖；要點：</a:t>
+            </a:r>
+          </a:p>
+          <a:p>
+            <a:r>
+              <a:t>• classify → 依信心分路：P(誤判) ≥ 0.961 排除、缺陷 ≥ 0.996 且非 open 確認——82.2% 在這裡結束</a:t>
+            </a:r>
+          </a:p>
+          <a:p>
+            <a:r>
+              <a:t>• 其餘：取得脈絡（3 個 MCP 工具，標準依類別限定）→ LLM 寫說明（僅說明，60 秒上限）→ 信心 ≥ 0.961 決定，否則交給人</a:t>
+            </a:r>
+          </a:p>
+          <a:p>
+            <a:r>
+              <a:t>• 交給人 = LangGraph interrupt()，checkpoint 存 SQLite；作業員兩天後回來續跑，不重跑工具</a:t>
+            </a:r>
+          </a:p>
+          <a:p/>
+          <a:p>
+            <a:r>
               <a:t>講稿 1. 這張是處置路徑，程式自己畫的。</a:t>
             </a:r>
           </a:p>
@@ -4121,6 +4173,27 @@
           <a:p>
             <a:r>
               <a:t>白話：模型只做兩件事——決定查什麼、把結果寫成話；中間的驗證、平行查詢、畫圖、存檔都是程式。</a:t>
+            </a:r>
+          </a:p>
+          <a:p/>
+          <a:p>
+            <a:r>
+              <a:t>頁面上只有圖；要點：</a:t>
+            </a:r>
+          </a:p>
+          <a:p>
+            <a:r>
+              <a:t>• 規劃（LLM #1）→ 驗證：工具名、參數名、參數值都對照真實簽名與值域，L4 這種不存在的產線直接拒絕、不重試</a:t>
+            </a:r>
+          </a:p>
+          <a:p>
+            <a:r>
+              <a:t>• Send 平行展開——因為那幾個事實彼此獨立，不是為了快；工具幾毫秒，模型呼叫二十幾秒</a:t>
+            </a:r>
+          </a:p>
+          <a:p>
+            <a:r>
+              <a:t>• 收集 → 圖從結果的形狀推（模型不能選圓餅圖）→ 撰寫（LLM #2）→ 存 analysis_runs，圖從存的資料重畫、不重跑計畫</a:t>
             </a:r>
           </a:p>
           <a:p/>
@@ -22118,8 +22191,8 @@
         </p:blipFill>
         <p:spPr>
           <a:xfrm>
-            <a:off x="548640" y="1188720"/>
-            <a:ext cx="5996065" cy="4572000"/>
+            <a:off x="2544394" y="1005840"/>
+            <a:ext cx="7102907" cy="4846320"/>
           </a:xfrm>
           <a:prstGeom prst="rect">
             <a:avLst/>
@@ -22129,154 +22202,6 @@
       <p:sp>
         <p:nvSpPr>
           <p:cNvPr id="4" name="TextBox 3"/>
-          <p:cNvSpPr txBox="1"/>
-          <p:nvPr/>
-        </p:nvSpPr>
-        <p:spPr>
-          <a:xfrm>
-            <a:off x="8412480" y="1188720"/>
-            <a:ext cx="3383280" cy="4754880"/>
-          </a:xfrm>
-          <a:prstGeom prst="rect">
-            <a:avLst/>
-          </a:prstGeom>
-          <a:noFill/>
-        </p:spPr>
-        <p:txBody>
-          <a:bodyPr wrap="square">
-            <a:spAutoFit/>
-          </a:bodyPr>
-          <a:lstStyle/>
-          <a:p>
-            <a:pPr>
-              <a:lnSpc>
-                <a:spcPct val="125000"/>
-              </a:lnSpc>
-            </a:pPr>
-            <a:r>
-              <a:rPr sz="1300" b="0">
-                <a:solidFill>
-                  <a:srgbClr val="6FC7CF"/>
-                </a:solidFill>
-                <a:latin typeface="Noto Sans TC"/>
-              </a:rPr>
-              <a:t>• </a:t>
-            </a:r>
-            <a:r>
-              <a:rPr sz="1300" b="0">
-                <a:solidFill>
-                  <a:srgbClr val="E8E6E1"/>
-                </a:solidFill>
-                <a:latin typeface="Noto Sans TC"/>
-              </a:rPr>
-              <a:t>相減前端：樣板減待測，產生候選（也就是「AOI」）</a:t>
-            </a:r>
-          </a:p>
-          <a:p>
-            <a:pPr>
-              <a:lnSpc>
-                <a:spcPct val="125000"/>
-              </a:lnSpc>
-            </a:pPr>
-            <a:r>
-              <a:rPr sz="1300" b="0">
-                <a:solidFill>
-                  <a:srgbClr val="6FC7CF"/>
-                </a:solidFill>
-                <a:latin typeface="Noto Sans TC"/>
-              </a:rPr>
-              <a:t>• </a:t>
-            </a:r>
-            <a:r>
-              <a:rPr sz="1300" b="0">
-                <a:solidFill>
-                  <a:srgbClr val="E8E6E1"/>
-                </a:solidFill>
-                <a:latin typeface="Noto Sans TC"/>
-              </a:rPr>
-              <a:t>複判模型：ResNet-18 看每個候選，給 P(false call) 和六類機率</a:t>
-            </a:r>
-          </a:p>
-          <a:p>
-            <a:pPr>
-              <a:lnSpc>
-                <a:spcPct val="125000"/>
-              </a:lnSpc>
-            </a:pPr>
-            <a:r>
-              <a:rPr sz="1300" b="0">
-                <a:solidFill>
-                  <a:srgbClr val="6FC7CF"/>
-                </a:solidFill>
-                <a:latin typeface="Noto Sans TC"/>
-              </a:rPr>
-              <a:t>• </a:t>
-            </a:r>
-            <a:r>
-              <a:rPr sz="1300" b="0">
-                <a:solidFill>
-                  <a:srgbClr val="E8E6E1"/>
-                </a:solidFill>
-                <a:latin typeface="Noto Sans TC"/>
-              </a:rPr>
-              <a:t>門檻與路由：兩個數字決定誰直接處置、誰交給人</a:t>
-            </a:r>
-          </a:p>
-          <a:p>
-            <a:pPr>
-              <a:lnSpc>
-                <a:spcPct val="125000"/>
-              </a:lnSpc>
-            </a:pPr>
-            <a:r>
-              <a:rPr sz="1300" b="0">
-                <a:solidFill>
-                  <a:srgbClr val="6FC7CF"/>
-                </a:solidFill>
-                <a:latin typeface="Noto Sans TC"/>
-              </a:rPr>
-              <a:t>• </a:t>
-            </a:r>
-            <a:r>
-              <a:rPr sz="1300" b="0">
-                <a:solidFill>
-                  <a:srgbClr val="E8E6E1"/>
-                </a:solidFill>
-                <a:latin typeface="Noto Sans TC"/>
-              </a:rPr>
-              <a:t>Agent 與站台：LLM 寫說明、人做判定、每個判定記名字和模型版本</a:t>
-            </a:r>
-          </a:p>
-          <a:p>
-            <a:pPr>
-              <a:lnSpc>
-                <a:spcPct val="125000"/>
-              </a:lnSpc>
-            </a:pPr>
-            <a:r>
-              <a:rPr sz="1300" b="0">
-                <a:solidFill>
-                  <a:srgbClr val="6FC7CF"/>
-                </a:solidFill>
-                <a:latin typeface="Noto Sans TC"/>
-              </a:rPr>
-              <a:t>• </a:t>
-            </a:r>
-            <a:r>
-              <a:rPr sz="1300" b="0">
-                <a:solidFill>
-                  <a:srgbClr val="E8E6E1"/>
-                </a:solidFill>
-                <a:latin typeface="Noto Sans TC"/>
-              </a:rPr>
-              <a:t>/ask：主管問一句話，系統規劃查詢、驗證、查完畫圖寫答案</a:t>
-            </a:r>
-          </a:p>
-        </p:txBody>
-      </p:sp>
-      <p:sp>
-        <p:nvSpPr>
-          <p:cNvPr id="5" name="TextBox 4"/>
           <p:cNvSpPr txBox="1"/>
           <p:nvPr/>
         </p:nvSpPr>
@@ -22315,7 +22240,7 @@
       </p:sp>
       <p:sp>
         <p:nvSpPr>
-          <p:cNvPr id="6" name="TextBox 5"/>
+          <p:cNvPr id="5" name="TextBox 4"/>
           <p:cNvSpPr txBox="1"/>
           <p:nvPr/>
         </p:nvSpPr>
@@ -22354,7 +22279,7 @@
       </p:sp>
       <p:sp>
         <p:nvSpPr>
-          <p:cNvPr id="7" name="TextBox 6"/>
+          <p:cNvPr id="6" name="TextBox 5"/>
           <p:cNvSpPr txBox="1"/>
           <p:nvPr/>
         </p:nvSpPr>
@@ -22472,8 +22397,8 @@
         </p:blipFill>
         <p:spPr>
           <a:xfrm>
-            <a:off x="548640" y="1188720"/>
-            <a:ext cx="5656082" cy="4572000"/>
+            <a:off x="3115490" y="1005840"/>
+            <a:ext cx="5960714" cy="4846320"/>
           </a:xfrm>
           <a:prstGeom prst="rect">
             <a:avLst/>
@@ -22483,104 +22408,6 @@
       <p:sp>
         <p:nvSpPr>
           <p:cNvPr id="4" name="TextBox 3"/>
-          <p:cNvSpPr txBox="1"/>
-          <p:nvPr/>
-        </p:nvSpPr>
-        <p:spPr>
-          <a:xfrm>
-            <a:off x="8412480" y="1188720"/>
-            <a:ext cx="3383280" cy="4754880"/>
-          </a:xfrm>
-          <a:prstGeom prst="rect">
-            <a:avLst/>
-          </a:prstGeom>
-          <a:noFill/>
-        </p:spPr>
-        <p:txBody>
-          <a:bodyPr wrap="square">
-            <a:spAutoFit/>
-          </a:bodyPr>
-          <a:lstStyle/>
-          <a:p>
-            <a:pPr>
-              <a:lnSpc>
-                <a:spcPct val="125000"/>
-              </a:lnSpc>
-            </a:pPr>
-            <a:r>
-              <a:rPr sz="1300" b="0">
-                <a:solidFill>
-                  <a:srgbClr val="6FC7CF"/>
-                </a:solidFill>
-                <a:latin typeface="Noto Sans TC"/>
-              </a:rPr>
-              <a:t>• </a:t>
-            </a:r>
-            <a:r>
-              <a:rPr sz="1300" b="0">
-                <a:solidFill>
-                  <a:srgbClr val="E8E6E1"/>
-                </a:solidFill>
-                <a:latin typeface="Noto Sans TC"/>
-              </a:rPr>
-              <a:t>classify → 依信心分路：P(誤判) ≥ 0.961 排除、缺陷 ≥ 0.996 且非 open 確認——82.2% 在這裡結束</a:t>
-            </a:r>
-          </a:p>
-          <a:p>
-            <a:pPr>
-              <a:lnSpc>
-                <a:spcPct val="125000"/>
-              </a:lnSpc>
-            </a:pPr>
-            <a:r>
-              <a:rPr sz="1300" b="0">
-                <a:solidFill>
-                  <a:srgbClr val="6FC7CF"/>
-                </a:solidFill>
-                <a:latin typeface="Noto Sans TC"/>
-              </a:rPr>
-              <a:t>• </a:t>
-            </a:r>
-            <a:r>
-              <a:rPr sz="1300" b="0">
-                <a:solidFill>
-                  <a:srgbClr val="E8E6E1"/>
-                </a:solidFill>
-                <a:latin typeface="Noto Sans TC"/>
-              </a:rPr>
-              <a:t>其餘：取得脈絡（3 個 MCP 工具，標準依類別限定）→ LLM 寫說明（僅說明，60 秒上限）→ 信心 ≥ 0.961 決定，否則交給人</a:t>
-            </a:r>
-          </a:p>
-          <a:p>
-            <a:pPr>
-              <a:lnSpc>
-                <a:spcPct val="125000"/>
-              </a:lnSpc>
-            </a:pPr>
-            <a:r>
-              <a:rPr sz="1300" b="0">
-                <a:solidFill>
-                  <a:srgbClr val="6FC7CF"/>
-                </a:solidFill>
-                <a:latin typeface="Noto Sans TC"/>
-              </a:rPr>
-              <a:t>• </a:t>
-            </a:r>
-            <a:r>
-              <a:rPr sz="1300" b="0">
-                <a:solidFill>
-                  <a:srgbClr val="E8E6E1"/>
-                </a:solidFill>
-                <a:latin typeface="Noto Sans TC"/>
-              </a:rPr>
-              <a:t>交給人 = LangGraph interrupt()，checkpoint 存 SQLite；作業員兩天後回來續跑，不重跑工具</a:t>
-            </a:r>
-          </a:p>
-        </p:txBody>
-      </p:sp>
-      <p:sp>
-        <p:nvSpPr>
-          <p:cNvPr id="5" name="TextBox 4"/>
           <p:cNvSpPr txBox="1"/>
           <p:nvPr/>
         </p:nvSpPr>
@@ -22619,7 +22446,7 @@
       </p:sp>
       <p:sp>
         <p:nvSpPr>
-          <p:cNvPr id="6" name="TextBox 5"/>
+          <p:cNvPr id="5" name="TextBox 4"/>
           <p:cNvSpPr txBox="1"/>
           <p:nvPr/>
         </p:nvSpPr>
@@ -22658,7 +22485,7 @@
       </p:sp>
       <p:sp>
         <p:nvSpPr>
-          <p:cNvPr id="7" name="TextBox 6"/>
+          <p:cNvPr id="6" name="TextBox 5"/>
           <p:cNvSpPr txBox="1"/>
           <p:nvPr/>
         </p:nvSpPr>
@@ -22776,8 +22603,8 @@
         </p:blipFill>
         <p:spPr>
           <a:xfrm>
-            <a:off x="2471226" y="1188720"/>
-            <a:ext cx="7249243" cy="3566160"/>
+            <a:off x="929487" y="1005840"/>
+            <a:ext cx="10332720" cy="4846320"/>
           </a:xfrm>
           <a:prstGeom prst="rect">
             <a:avLst/>
@@ -22787,127 +22614,6 @@
       <p:sp>
         <p:nvSpPr>
           <p:cNvPr id="4" name="TextBox 3"/>
-          <p:cNvSpPr txBox="1"/>
-          <p:nvPr/>
-        </p:nvSpPr>
-        <p:spPr>
-          <a:xfrm>
-            <a:off x="548640" y="4892040"/>
-            <a:ext cx="5440680" cy="914400"/>
-          </a:xfrm>
-          <a:prstGeom prst="rect">
-            <a:avLst/>
-          </a:prstGeom>
-          <a:noFill/>
-        </p:spPr>
-        <p:txBody>
-          <a:bodyPr wrap="square">
-            <a:spAutoFit/>
-          </a:bodyPr>
-          <a:lstStyle/>
-          <a:p>
-            <a:pPr>
-              <a:lnSpc>
-                <a:spcPct val="125000"/>
-              </a:lnSpc>
-            </a:pPr>
-            <a:r>
-              <a:rPr sz="1200" b="0">
-                <a:solidFill>
-                  <a:srgbClr val="6FC7CF"/>
-                </a:solidFill>
-                <a:latin typeface="Noto Sans TC"/>
-              </a:rPr>
-              <a:t>• </a:t>
-            </a:r>
-            <a:r>
-              <a:rPr sz="1200" b="0">
-                <a:solidFill>
-                  <a:srgbClr val="E8E6E1"/>
-                </a:solidFill>
-                <a:latin typeface="Noto Sans TC"/>
-              </a:rPr>
-              <a:t>規劃（LLM #1）→ 驗證：工具名、參數名、參數值都對照真實簽名與值域，L4 這種不存在的產線直接拒絕、不重試</a:t>
-            </a:r>
-          </a:p>
-          <a:p>
-            <a:pPr>
-              <a:lnSpc>
-                <a:spcPct val="125000"/>
-              </a:lnSpc>
-            </a:pPr>
-            <a:r>
-              <a:rPr sz="1200" b="0">
-                <a:solidFill>
-                  <a:srgbClr val="6FC7CF"/>
-                </a:solidFill>
-                <a:latin typeface="Noto Sans TC"/>
-              </a:rPr>
-              <a:t>• </a:t>
-            </a:r>
-            <a:r>
-              <a:rPr sz="1200" b="0">
-                <a:solidFill>
-                  <a:srgbClr val="E8E6E1"/>
-                </a:solidFill>
-                <a:latin typeface="Noto Sans TC"/>
-              </a:rPr>
-              <a:t>Send 平行展開——因為那幾個事實彼此獨立，不是為了快；工具幾毫秒，模型呼叫二十幾秒</a:t>
-            </a:r>
-          </a:p>
-        </p:txBody>
-      </p:sp>
-      <p:sp>
-        <p:nvSpPr>
-          <p:cNvPr id="5" name="TextBox 4"/>
-          <p:cNvSpPr txBox="1"/>
-          <p:nvPr/>
-        </p:nvSpPr>
-        <p:spPr>
-          <a:xfrm>
-            <a:off x="6172200" y="4892040"/>
-            <a:ext cx="5440680" cy="914400"/>
-          </a:xfrm>
-          <a:prstGeom prst="rect">
-            <a:avLst/>
-          </a:prstGeom>
-          <a:noFill/>
-        </p:spPr>
-        <p:txBody>
-          <a:bodyPr wrap="square">
-            <a:spAutoFit/>
-          </a:bodyPr>
-          <a:lstStyle/>
-          <a:p>
-            <a:pPr>
-              <a:lnSpc>
-                <a:spcPct val="125000"/>
-              </a:lnSpc>
-            </a:pPr>
-            <a:r>
-              <a:rPr sz="1200" b="0">
-                <a:solidFill>
-                  <a:srgbClr val="6FC7CF"/>
-                </a:solidFill>
-                <a:latin typeface="Noto Sans TC"/>
-              </a:rPr>
-              <a:t>• </a:t>
-            </a:r>
-            <a:r>
-              <a:rPr sz="1200" b="0">
-                <a:solidFill>
-                  <a:srgbClr val="E8E6E1"/>
-                </a:solidFill>
-                <a:latin typeface="Noto Sans TC"/>
-              </a:rPr>
-              <a:t>收集 → 圖從結果的形狀推（模型不能選圓餅圖）→ 撰寫（LLM #2）→ 存 analysis_runs，圖從存的資料重畫、不重跑計畫</a:t>
-            </a:r>
-          </a:p>
-        </p:txBody>
-      </p:sp>
-      <p:sp>
-        <p:nvSpPr>
-          <p:cNvPr id="6" name="TextBox 5"/>
           <p:cNvSpPr txBox="1"/>
           <p:nvPr/>
         </p:nvSpPr>
@@ -22946,7 +22652,7 @@
       </p:sp>
       <p:sp>
         <p:nvSpPr>
-          <p:cNvPr id="7" name="TextBox 6"/>
+          <p:cNvPr id="5" name="TextBox 4"/>
           <p:cNvSpPr txBox="1"/>
           <p:nvPr/>
         </p:nvSpPr>
@@ -22985,7 +22691,7 @@
       </p:sp>
       <p:sp>
         <p:nvSpPr>
-          <p:cNvPr id="8" name="TextBox 7"/>
+          <p:cNvPr id="6" name="TextBox 5"/>
           <p:cNvSpPr txBox="1"/>
           <p:nvPr/>
         </p:nvSpPr>

</xml_diff>

<commit_message>
Deck: the problem on a warm band, the answer on the accent band; the station slides named for what they show
Co-Authored-By: Claude Fable 5 <noreply@anthropic.com>
</commit_message>
<xml_diff>
--- a/docs/deck/aoi-agent-journey.zh-TW.pptx
+++ b/docs/deck/aoi-agent-journey.zh-TW.pptx
@@ -9083,7 +9083,51 @@
       </p:sp>
       <p:sp>
         <p:nvSpPr>
-          <p:cNvPr id="19" name="TextBox 18"/>
+          <p:cNvPr id="19" name="Rectangle 18"/>
+          <p:cNvSpPr/>
+          <p:nvPr/>
+        </p:nvSpPr>
+        <p:spPr>
+          <a:xfrm>
+            <a:off x="320040" y="4517134"/>
+            <a:ext cx="11521440" cy="676655"/>
+          </a:xfrm>
+          <a:prstGeom prst="rect">
+            <a:avLst/>
+          </a:prstGeom>
+          <a:solidFill>
+            <a:srgbClr val="2B2416"/>
+          </a:solidFill>
+          <a:ln>
+            <a:noFill/>
+          </a:ln>
+          <a:effectLst/>
+        </p:spPr>
+        <p:style>
+          <a:lnRef idx="1">
+            <a:schemeClr val="accent1"/>
+          </a:lnRef>
+          <a:fillRef idx="3">
+            <a:schemeClr val="accent1"/>
+          </a:fillRef>
+          <a:effectRef idx="2">
+            <a:schemeClr val="accent1"/>
+          </a:effectRef>
+          <a:fontRef idx="minor">
+            <a:schemeClr val="lt1"/>
+          </a:fontRef>
+        </p:style>
+        <p:txBody>
+          <a:bodyPr rtlCol="0" anchor="ctr"/>
+          <a:lstStyle/>
+          <a:p>
+            <a:pPr algn="ctr"/>
+          </a:p>
+        </p:txBody>
+      </p:sp>
+      <p:sp>
+        <p:nvSpPr>
+          <p:cNvPr id="20" name="TextBox 19"/>
           <p:cNvSpPr txBox="1"/>
           <p:nvPr/>
         </p:nvSpPr>
@@ -9122,7 +9166,7 @@
       </p:sp>
       <p:sp>
         <p:nvSpPr>
-          <p:cNvPr id="20" name="TextBox 19"/>
+          <p:cNvPr id="21" name="TextBox 20"/>
           <p:cNvSpPr txBox="1"/>
           <p:nvPr/>
         </p:nvSpPr>
@@ -9197,7 +9241,51 @@
       </p:sp>
       <p:sp>
         <p:nvSpPr>
-          <p:cNvPr id="21" name="TextBox 20"/>
+          <p:cNvPr id="22" name="Rectangle 21"/>
+          <p:cNvSpPr/>
+          <p:nvPr/>
+        </p:nvSpPr>
+        <p:spPr>
+          <a:xfrm>
+            <a:off x="320040" y="5248653"/>
+            <a:ext cx="11521440" cy="676655"/>
+          </a:xfrm>
+          <a:prstGeom prst="rect">
+            <a:avLst/>
+          </a:prstGeom>
+          <a:solidFill>
+            <a:srgbClr val="16292B"/>
+          </a:solidFill>
+          <a:ln>
+            <a:noFill/>
+          </a:ln>
+          <a:effectLst/>
+        </p:spPr>
+        <p:style>
+          <a:lnRef idx="1">
+            <a:schemeClr val="accent1"/>
+          </a:lnRef>
+          <a:fillRef idx="3">
+            <a:schemeClr val="accent1"/>
+          </a:fillRef>
+          <a:effectRef idx="2">
+            <a:schemeClr val="accent1"/>
+          </a:effectRef>
+          <a:fontRef idx="minor">
+            <a:schemeClr val="lt1"/>
+          </a:fontRef>
+        </p:style>
+        <p:txBody>
+          <a:bodyPr rtlCol="0" anchor="ctr"/>
+          <a:lstStyle/>
+          <a:p>
+            <a:pPr algn="ctr"/>
+          </a:p>
+        </p:txBody>
+      </p:sp>
+      <p:sp>
+        <p:nvSpPr>
+          <p:cNvPr id="23" name="TextBox 22"/>
           <p:cNvSpPr txBox="1"/>
           <p:nvPr/>
         </p:nvSpPr>
@@ -9236,7 +9324,7 @@
       </p:sp>
       <p:sp>
         <p:nvSpPr>
-          <p:cNvPr id="22" name="TextBox 21"/>
+          <p:cNvPr id="24" name="TextBox 23"/>
           <p:cNvSpPr txBox="1"/>
           <p:nvPr/>
         </p:nvSpPr>
@@ -9275,7 +9363,7 @@
       </p:sp>
       <p:sp>
         <p:nvSpPr>
-          <p:cNvPr id="23" name="TextBox 22"/>
+          <p:cNvPr id="25" name="TextBox 24"/>
           <p:cNvSpPr txBox="1"/>
           <p:nvPr/>
         </p:nvSpPr>
@@ -9314,7 +9402,7 @@
       </p:sp>
       <p:sp>
         <p:nvSpPr>
-          <p:cNvPr id="24" name="TextBox 23"/>
+          <p:cNvPr id="26" name="TextBox 25"/>
           <p:cNvSpPr txBox="1"/>
           <p:nvPr/>
         </p:nvSpPr>
@@ -11005,7 +11093,51 @@
       </p:sp>
       <p:sp>
         <p:nvSpPr>
-          <p:cNvPr id="19" name="TextBox 18"/>
+          <p:cNvPr id="19" name="Rectangle 18"/>
+          <p:cNvSpPr/>
+          <p:nvPr/>
+        </p:nvSpPr>
+        <p:spPr>
+          <a:xfrm>
+            <a:off x="320040" y="4901184"/>
+            <a:ext cx="11521440" cy="640080"/>
+          </a:xfrm>
+          <a:prstGeom prst="rect">
+            <a:avLst/>
+          </a:prstGeom>
+          <a:solidFill>
+            <a:srgbClr val="2B2416"/>
+          </a:solidFill>
+          <a:ln>
+            <a:noFill/>
+          </a:ln>
+          <a:effectLst/>
+        </p:spPr>
+        <p:style>
+          <a:lnRef idx="1">
+            <a:schemeClr val="accent1"/>
+          </a:lnRef>
+          <a:fillRef idx="3">
+            <a:schemeClr val="accent1"/>
+          </a:fillRef>
+          <a:effectRef idx="2">
+            <a:schemeClr val="accent1"/>
+          </a:effectRef>
+          <a:fontRef idx="minor">
+            <a:schemeClr val="lt1"/>
+          </a:fontRef>
+        </p:style>
+        <p:txBody>
+          <a:bodyPr rtlCol="0" anchor="ctr"/>
+          <a:lstStyle/>
+          <a:p>
+            <a:pPr algn="ctr"/>
+          </a:p>
+        </p:txBody>
+      </p:sp>
+      <p:sp>
+        <p:nvSpPr>
+          <p:cNvPr id="20" name="TextBox 19"/>
           <p:cNvSpPr txBox="1"/>
           <p:nvPr/>
         </p:nvSpPr>
@@ -11044,7 +11176,7 @@
       </p:sp>
       <p:sp>
         <p:nvSpPr>
-          <p:cNvPr id="20" name="TextBox 19"/>
+          <p:cNvPr id="21" name="TextBox 20"/>
           <p:cNvSpPr txBox="1"/>
           <p:nvPr/>
         </p:nvSpPr>
@@ -11110,7 +11242,51 @@
       </p:sp>
       <p:sp>
         <p:nvSpPr>
-          <p:cNvPr id="21" name="TextBox 20"/>
+          <p:cNvPr id="22" name="Rectangle 21"/>
+          <p:cNvSpPr/>
+          <p:nvPr/>
+        </p:nvSpPr>
+        <p:spPr>
+          <a:xfrm>
+            <a:off x="320040" y="5596128"/>
+            <a:ext cx="11521440" cy="640080"/>
+          </a:xfrm>
+          <a:prstGeom prst="rect">
+            <a:avLst/>
+          </a:prstGeom>
+          <a:solidFill>
+            <a:srgbClr val="16292B"/>
+          </a:solidFill>
+          <a:ln>
+            <a:noFill/>
+          </a:ln>
+          <a:effectLst/>
+        </p:spPr>
+        <p:style>
+          <a:lnRef idx="1">
+            <a:schemeClr val="accent1"/>
+          </a:lnRef>
+          <a:fillRef idx="3">
+            <a:schemeClr val="accent1"/>
+          </a:fillRef>
+          <a:effectRef idx="2">
+            <a:schemeClr val="accent1"/>
+          </a:effectRef>
+          <a:fontRef idx="minor">
+            <a:schemeClr val="lt1"/>
+          </a:fontRef>
+        </p:style>
+        <p:txBody>
+          <a:bodyPr rtlCol="0" anchor="ctr"/>
+          <a:lstStyle/>
+          <a:p>
+            <a:pPr algn="ctr"/>
+          </a:p>
+        </p:txBody>
+      </p:sp>
+      <p:sp>
+        <p:nvSpPr>
+          <p:cNvPr id="23" name="TextBox 22"/>
           <p:cNvSpPr txBox="1"/>
           <p:nvPr/>
         </p:nvSpPr>
@@ -11149,7 +11325,7 @@
       </p:sp>
       <p:sp>
         <p:nvSpPr>
-          <p:cNvPr id="22" name="TextBox 21"/>
+          <p:cNvPr id="24" name="TextBox 23"/>
           <p:cNvSpPr txBox="1"/>
           <p:nvPr/>
         </p:nvSpPr>
@@ -11224,7 +11400,7 @@
       </p:sp>
       <p:sp>
         <p:nvSpPr>
-          <p:cNvPr id="23" name="TextBox 22"/>
+          <p:cNvPr id="25" name="TextBox 24"/>
           <p:cNvSpPr txBox="1"/>
           <p:nvPr/>
         </p:nvSpPr>
@@ -11263,7 +11439,7 @@
       </p:sp>
       <p:sp>
         <p:nvSpPr>
-          <p:cNvPr id="24" name="TextBox 23"/>
+          <p:cNvPr id="26" name="TextBox 25"/>
           <p:cNvSpPr txBox="1"/>
           <p:nvPr/>
         </p:nvSpPr>
@@ -12117,7 +12293,51 @@
       </p:sp>
       <p:sp>
         <p:nvSpPr>
-          <p:cNvPr id="18" name="TextBox 17"/>
+          <p:cNvPr id="18" name="Rectangle 17"/>
+          <p:cNvSpPr/>
+          <p:nvPr/>
+        </p:nvSpPr>
+        <p:spPr>
+          <a:xfrm>
+            <a:off x="320040" y="4727448"/>
+            <a:ext cx="11521440" cy="713232"/>
+          </a:xfrm>
+          <a:prstGeom prst="rect">
+            <a:avLst/>
+          </a:prstGeom>
+          <a:solidFill>
+            <a:srgbClr val="2B2416"/>
+          </a:solidFill>
+          <a:ln>
+            <a:noFill/>
+          </a:ln>
+          <a:effectLst/>
+        </p:spPr>
+        <p:style>
+          <a:lnRef idx="1">
+            <a:schemeClr val="accent1"/>
+          </a:lnRef>
+          <a:fillRef idx="3">
+            <a:schemeClr val="accent1"/>
+          </a:fillRef>
+          <a:effectRef idx="2">
+            <a:schemeClr val="accent1"/>
+          </a:effectRef>
+          <a:fontRef idx="minor">
+            <a:schemeClr val="lt1"/>
+          </a:fontRef>
+        </p:style>
+        <p:txBody>
+          <a:bodyPr rtlCol="0" anchor="ctr"/>
+          <a:lstStyle/>
+          <a:p>
+            <a:pPr algn="ctr"/>
+          </a:p>
+        </p:txBody>
+      </p:sp>
+      <p:sp>
+        <p:nvSpPr>
+          <p:cNvPr id="19" name="TextBox 18"/>
           <p:cNvSpPr txBox="1"/>
           <p:nvPr/>
         </p:nvSpPr>
@@ -12156,7 +12376,7 @@
       </p:sp>
       <p:sp>
         <p:nvSpPr>
-          <p:cNvPr id="19" name="TextBox 18"/>
+          <p:cNvPr id="20" name="TextBox 19"/>
           <p:cNvSpPr txBox="1"/>
           <p:nvPr/>
         </p:nvSpPr>
@@ -12195,7 +12415,51 @@
       </p:sp>
       <p:sp>
         <p:nvSpPr>
-          <p:cNvPr id="20" name="TextBox 19"/>
+          <p:cNvPr id="21" name="Rectangle 20"/>
+          <p:cNvSpPr/>
+          <p:nvPr/>
+        </p:nvSpPr>
+        <p:spPr>
+          <a:xfrm>
+            <a:off x="320040" y="5495544"/>
+            <a:ext cx="11521440" cy="713232"/>
+          </a:xfrm>
+          <a:prstGeom prst="rect">
+            <a:avLst/>
+          </a:prstGeom>
+          <a:solidFill>
+            <a:srgbClr val="16292B"/>
+          </a:solidFill>
+          <a:ln>
+            <a:noFill/>
+          </a:ln>
+          <a:effectLst/>
+        </p:spPr>
+        <p:style>
+          <a:lnRef idx="1">
+            <a:schemeClr val="accent1"/>
+          </a:lnRef>
+          <a:fillRef idx="3">
+            <a:schemeClr val="accent1"/>
+          </a:fillRef>
+          <a:effectRef idx="2">
+            <a:schemeClr val="accent1"/>
+          </a:effectRef>
+          <a:fontRef idx="minor">
+            <a:schemeClr val="lt1"/>
+          </a:fontRef>
+        </p:style>
+        <p:txBody>
+          <a:bodyPr rtlCol="0" anchor="ctr"/>
+          <a:lstStyle/>
+          <a:p>
+            <a:pPr algn="ctr"/>
+          </a:p>
+        </p:txBody>
+      </p:sp>
+      <p:sp>
+        <p:nvSpPr>
+          <p:cNvPr id="22" name="TextBox 21"/>
           <p:cNvSpPr txBox="1"/>
           <p:nvPr/>
         </p:nvSpPr>
@@ -12234,7 +12498,7 @@
       </p:sp>
       <p:sp>
         <p:nvSpPr>
-          <p:cNvPr id="21" name="TextBox 20"/>
+          <p:cNvPr id="23" name="TextBox 22"/>
           <p:cNvSpPr txBox="1"/>
           <p:nvPr/>
         </p:nvSpPr>
@@ -12291,7 +12555,7 @@
       </p:sp>
       <p:sp>
         <p:nvSpPr>
-          <p:cNvPr id="22" name="TextBox 21"/>
+          <p:cNvPr id="24" name="TextBox 23"/>
           <p:cNvSpPr txBox="1"/>
           <p:nvPr/>
         </p:nvSpPr>
@@ -12330,7 +12594,7 @@
       </p:sp>
       <p:sp>
         <p:nvSpPr>
-          <p:cNvPr id="23" name="TextBox 22"/>
+          <p:cNvPr id="25" name="TextBox 24"/>
           <p:cNvSpPr txBox="1"/>
           <p:nvPr/>
         </p:nvSpPr>
@@ -13184,7 +13448,51 @@
       </p:sp>
       <p:sp>
         <p:nvSpPr>
-          <p:cNvPr id="18" name="TextBox 17"/>
+          <p:cNvPr id="18" name="Rectangle 17"/>
+          <p:cNvSpPr/>
+          <p:nvPr/>
+        </p:nvSpPr>
+        <p:spPr>
+          <a:xfrm>
+            <a:off x="320040" y="4599429"/>
+            <a:ext cx="11521440" cy="676655"/>
+          </a:xfrm>
+          <a:prstGeom prst="rect">
+            <a:avLst/>
+          </a:prstGeom>
+          <a:solidFill>
+            <a:srgbClr val="2B2416"/>
+          </a:solidFill>
+          <a:ln>
+            <a:noFill/>
+          </a:ln>
+          <a:effectLst/>
+        </p:spPr>
+        <p:style>
+          <a:lnRef idx="1">
+            <a:schemeClr val="accent1"/>
+          </a:lnRef>
+          <a:fillRef idx="3">
+            <a:schemeClr val="accent1"/>
+          </a:fillRef>
+          <a:effectRef idx="2">
+            <a:schemeClr val="accent1"/>
+          </a:effectRef>
+          <a:fontRef idx="minor">
+            <a:schemeClr val="lt1"/>
+          </a:fontRef>
+        </p:style>
+        <p:txBody>
+          <a:bodyPr rtlCol="0" anchor="ctr"/>
+          <a:lstStyle/>
+          <a:p>
+            <a:pPr algn="ctr"/>
+          </a:p>
+        </p:txBody>
+      </p:sp>
+      <p:sp>
+        <p:nvSpPr>
+          <p:cNvPr id="19" name="TextBox 18"/>
           <p:cNvSpPr txBox="1"/>
           <p:nvPr/>
         </p:nvSpPr>
@@ -13223,7 +13531,7 @@
       </p:sp>
       <p:sp>
         <p:nvSpPr>
-          <p:cNvPr id="19" name="TextBox 18"/>
+          <p:cNvPr id="20" name="TextBox 19"/>
           <p:cNvSpPr txBox="1"/>
           <p:nvPr/>
         </p:nvSpPr>
@@ -13280,7 +13588,51 @@
       </p:sp>
       <p:sp>
         <p:nvSpPr>
-          <p:cNvPr id="20" name="TextBox 19"/>
+          <p:cNvPr id="21" name="Rectangle 20"/>
+          <p:cNvSpPr/>
+          <p:nvPr/>
+        </p:nvSpPr>
+        <p:spPr>
+          <a:xfrm>
+            <a:off x="320040" y="5330948"/>
+            <a:ext cx="11521440" cy="941831"/>
+          </a:xfrm>
+          <a:prstGeom prst="rect">
+            <a:avLst/>
+          </a:prstGeom>
+          <a:solidFill>
+            <a:srgbClr val="16292B"/>
+          </a:solidFill>
+          <a:ln>
+            <a:noFill/>
+          </a:ln>
+          <a:effectLst/>
+        </p:spPr>
+        <p:style>
+          <a:lnRef idx="1">
+            <a:schemeClr val="accent1"/>
+          </a:lnRef>
+          <a:fillRef idx="3">
+            <a:schemeClr val="accent1"/>
+          </a:fillRef>
+          <a:effectRef idx="2">
+            <a:schemeClr val="accent1"/>
+          </a:effectRef>
+          <a:fontRef idx="minor">
+            <a:schemeClr val="lt1"/>
+          </a:fontRef>
+        </p:style>
+        <p:txBody>
+          <a:bodyPr rtlCol="0" anchor="ctr"/>
+          <a:lstStyle/>
+          <a:p>
+            <a:pPr algn="ctr"/>
+          </a:p>
+        </p:txBody>
+      </p:sp>
+      <p:sp>
+        <p:nvSpPr>
+          <p:cNvPr id="22" name="TextBox 21"/>
           <p:cNvSpPr txBox="1"/>
           <p:nvPr/>
         </p:nvSpPr>
@@ -13319,7 +13671,7 @@
       </p:sp>
       <p:sp>
         <p:nvSpPr>
-          <p:cNvPr id="21" name="TextBox 20"/>
+          <p:cNvPr id="23" name="TextBox 22"/>
           <p:cNvSpPr txBox="1"/>
           <p:nvPr/>
         </p:nvSpPr>
@@ -13358,7 +13710,7 @@
       </p:sp>
       <p:sp>
         <p:nvSpPr>
-          <p:cNvPr id="22" name="TextBox 21"/>
+          <p:cNvPr id="24" name="TextBox 23"/>
           <p:cNvSpPr txBox="1"/>
           <p:nvPr/>
         </p:nvSpPr>
@@ -13397,7 +13749,7 @@
       </p:sp>
       <p:sp>
         <p:nvSpPr>
-          <p:cNvPr id="23" name="TextBox 22"/>
+          <p:cNvPr id="25" name="TextBox 24"/>
           <p:cNvSpPr txBox="1"/>
           <p:nvPr/>
         </p:nvSpPr>
@@ -14209,7 +14561,51 @@
       </p:sp>
       <p:sp>
         <p:nvSpPr>
-          <p:cNvPr id="19" name="TextBox 18"/>
+          <p:cNvPr id="19" name="Rectangle 18"/>
+          <p:cNvSpPr/>
+          <p:nvPr/>
+        </p:nvSpPr>
+        <p:spPr>
+          <a:xfrm>
+            <a:off x="320040" y="4407408"/>
+            <a:ext cx="11521440" cy="393192"/>
+          </a:xfrm>
+          <a:prstGeom prst="rect">
+            <a:avLst/>
+          </a:prstGeom>
+          <a:solidFill>
+            <a:srgbClr val="2B2416"/>
+          </a:solidFill>
+          <a:ln>
+            <a:noFill/>
+          </a:ln>
+          <a:effectLst/>
+        </p:spPr>
+        <p:style>
+          <a:lnRef idx="1">
+            <a:schemeClr val="accent1"/>
+          </a:lnRef>
+          <a:fillRef idx="3">
+            <a:schemeClr val="accent1"/>
+          </a:fillRef>
+          <a:effectRef idx="2">
+            <a:schemeClr val="accent1"/>
+          </a:effectRef>
+          <a:fontRef idx="minor">
+            <a:schemeClr val="lt1"/>
+          </a:fontRef>
+        </p:style>
+        <p:txBody>
+          <a:bodyPr rtlCol="0" anchor="ctr"/>
+          <a:lstStyle/>
+          <a:p>
+            <a:pPr algn="ctr"/>
+          </a:p>
+        </p:txBody>
+      </p:sp>
+      <p:sp>
+        <p:nvSpPr>
+          <p:cNvPr id="20" name="TextBox 19"/>
           <p:cNvSpPr txBox="1"/>
           <p:nvPr/>
         </p:nvSpPr>
@@ -14248,7 +14644,7 @@
       </p:sp>
       <p:sp>
         <p:nvSpPr>
-          <p:cNvPr id="20" name="TextBox 19"/>
+          <p:cNvPr id="21" name="TextBox 20"/>
           <p:cNvSpPr txBox="1"/>
           <p:nvPr/>
         </p:nvSpPr>
@@ -14287,7 +14683,51 @@
       </p:sp>
       <p:sp>
         <p:nvSpPr>
-          <p:cNvPr id="21" name="TextBox 20"/>
+          <p:cNvPr id="22" name="Rectangle 21"/>
+          <p:cNvSpPr/>
+          <p:nvPr/>
+        </p:nvSpPr>
+        <p:spPr>
+          <a:xfrm>
+            <a:off x="320040" y="4855464"/>
+            <a:ext cx="11521440" cy="1133856"/>
+          </a:xfrm>
+          <a:prstGeom prst="rect">
+            <a:avLst/>
+          </a:prstGeom>
+          <a:solidFill>
+            <a:srgbClr val="16292B"/>
+          </a:solidFill>
+          <a:ln>
+            <a:noFill/>
+          </a:ln>
+          <a:effectLst/>
+        </p:spPr>
+        <p:style>
+          <a:lnRef idx="1">
+            <a:schemeClr val="accent1"/>
+          </a:lnRef>
+          <a:fillRef idx="3">
+            <a:schemeClr val="accent1"/>
+          </a:fillRef>
+          <a:effectRef idx="2">
+            <a:schemeClr val="accent1"/>
+          </a:effectRef>
+          <a:fontRef idx="minor">
+            <a:schemeClr val="lt1"/>
+          </a:fontRef>
+        </p:style>
+        <p:txBody>
+          <a:bodyPr rtlCol="0" anchor="ctr"/>
+          <a:lstStyle/>
+          <a:p>
+            <a:pPr algn="ctr"/>
+          </a:p>
+        </p:txBody>
+      </p:sp>
+      <p:sp>
+        <p:nvSpPr>
+          <p:cNvPr id="23" name="TextBox 22"/>
           <p:cNvSpPr txBox="1"/>
           <p:nvPr/>
         </p:nvSpPr>
@@ -14326,7 +14766,7 @@
       </p:sp>
       <p:sp>
         <p:nvSpPr>
-          <p:cNvPr id="22" name="TextBox 21"/>
+          <p:cNvPr id="24" name="TextBox 23"/>
           <p:cNvSpPr txBox="1"/>
           <p:nvPr/>
         </p:nvSpPr>
@@ -14419,7 +14859,7 @@
       </p:sp>
       <p:sp>
         <p:nvSpPr>
-          <p:cNvPr id="23" name="TextBox 22"/>
+          <p:cNvPr id="25" name="TextBox 24"/>
           <p:cNvSpPr txBox="1"/>
           <p:nvPr/>
         </p:nvSpPr>
@@ -14458,7 +14898,7 @@
       </p:sp>
       <p:sp>
         <p:nvSpPr>
-          <p:cNvPr id="24" name="TextBox 23"/>
+          <p:cNvPr id="26" name="TextBox 25"/>
           <p:cNvSpPr txBox="1"/>
           <p:nvPr/>
         </p:nvSpPr>
@@ -15513,7 +15953,51 @@
       </p:sp>
       <p:sp>
         <p:nvSpPr>
-          <p:cNvPr id="19" name="TextBox 18"/>
+          <p:cNvPr id="19" name="Rectangle 18"/>
+          <p:cNvSpPr/>
+          <p:nvPr/>
+        </p:nvSpPr>
+        <p:spPr>
+          <a:xfrm>
+            <a:off x="320040" y="4901184"/>
+            <a:ext cx="11521440" cy="640080"/>
+          </a:xfrm>
+          <a:prstGeom prst="rect">
+            <a:avLst/>
+          </a:prstGeom>
+          <a:solidFill>
+            <a:srgbClr val="2B2416"/>
+          </a:solidFill>
+          <a:ln>
+            <a:noFill/>
+          </a:ln>
+          <a:effectLst/>
+        </p:spPr>
+        <p:style>
+          <a:lnRef idx="1">
+            <a:schemeClr val="accent1"/>
+          </a:lnRef>
+          <a:fillRef idx="3">
+            <a:schemeClr val="accent1"/>
+          </a:fillRef>
+          <a:effectRef idx="2">
+            <a:schemeClr val="accent1"/>
+          </a:effectRef>
+          <a:fontRef idx="minor">
+            <a:schemeClr val="lt1"/>
+          </a:fontRef>
+        </p:style>
+        <p:txBody>
+          <a:bodyPr rtlCol="0" anchor="ctr"/>
+          <a:lstStyle/>
+          <a:p>
+            <a:pPr algn="ctr"/>
+          </a:p>
+        </p:txBody>
+      </p:sp>
+      <p:sp>
+        <p:nvSpPr>
+          <p:cNvPr id="20" name="TextBox 19"/>
           <p:cNvSpPr txBox="1"/>
           <p:nvPr/>
         </p:nvSpPr>
@@ -15552,7 +16036,7 @@
       </p:sp>
       <p:sp>
         <p:nvSpPr>
-          <p:cNvPr id="20" name="TextBox 19"/>
+          <p:cNvPr id="21" name="TextBox 20"/>
           <p:cNvSpPr txBox="1"/>
           <p:nvPr/>
         </p:nvSpPr>
@@ -15627,7 +16111,51 @@
       </p:sp>
       <p:sp>
         <p:nvSpPr>
-          <p:cNvPr id="21" name="TextBox 20"/>
+          <p:cNvPr id="22" name="Rectangle 21"/>
+          <p:cNvSpPr/>
+          <p:nvPr/>
+        </p:nvSpPr>
+        <p:spPr>
+          <a:xfrm>
+            <a:off x="320040" y="5596128"/>
+            <a:ext cx="11521440" cy="640080"/>
+          </a:xfrm>
+          <a:prstGeom prst="rect">
+            <a:avLst/>
+          </a:prstGeom>
+          <a:solidFill>
+            <a:srgbClr val="16292B"/>
+          </a:solidFill>
+          <a:ln>
+            <a:noFill/>
+          </a:ln>
+          <a:effectLst/>
+        </p:spPr>
+        <p:style>
+          <a:lnRef idx="1">
+            <a:schemeClr val="accent1"/>
+          </a:lnRef>
+          <a:fillRef idx="3">
+            <a:schemeClr val="accent1"/>
+          </a:fillRef>
+          <a:effectRef idx="2">
+            <a:schemeClr val="accent1"/>
+          </a:effectRef>
+          <a:fontRef idx="minor">
+            <a:schemeClr val="lt1"/>
+          </a:fontRef>
+        </p:style>
+        <p:txBody>
+          <a:bodyPr rtlCol="0" anchor="ctr"/>
+          <a:lstStyle/>
+          <a:p>
+            <a:pPr algn="ctr"/>
+          </a:p>
+        </p:txBody>
+      </p:sp>
+      <p:sp>
+        <p:nvSpPr>
+          <p:cNvPr id="23" name="TextBox 22"/>
           <p:cNvSpPr txBox="1"/>
           <p:nvPr/>
         </p:nvSpPr>
@@ -15666,7 +16194,7 @@
       </p:sp>
       <p:sp>
         <p:nvSpPr>
-          <p:cNvPr id="22" name="TextBox 21"/>
+          <p:cNvPr id="24" name="TextBox 23"/>
           <p:cNvSpPr txBox="1"/>
           <p:nvPr/>
         </p:nvSpPr>
@@ -15723,7 +16251,7 @@
       </p:sp>
       <p:sp>
         <p:nvSpPr>
-          <p:cNvPr id="23" name="TextBox 22"/>
+          <p:cNvPr id="25" name="TextBox 24"/>
           <p:cNvSpPr txBox="1"/>
           <p:nvPr/>
         </p:nvSpPr>
@@ -15762,7 +16290,7 @@
       </p:sp>
       <p:sp>
         <p:nvSpPr>
-          <p:cNvPr id="24" name="TextBox 23"/>
+          <p:cNvPr id="26" name="TextBox 25"/>
           <p:cNvSpPr txBox="1"/>
           <p:nvPr/>
         </p:nvSpPr>
@@ -16673,7 +17201,51 @@
       </p:sp>
       <p:sp>
         <p:nvSpPr>
-          <p:cNvPr id="19" name="TextBox 18"/>
+          <p:cNvPr id="19" name="Rectangle 18"/>
+          <p:cNvSpPr/>
+          <p:nvPr/>
+        </p:nvSpPr>
+        <p:spPr>
+          <a:xfrm>
+            <a:off x="320040" y="4407408"/>
+            <a:ext cx="11521440" cy="393192"/>
+          </a:xfrm>
+          <a:prstGeom prst="rect">
+            <a:avLst/>
+          </a:prstGeom>
+          <a:solidFill>
+            <a:srgbClr val="2B2416"/>
+          </a:solidFill>
+          <a:ln>
+            <a:noFill/>
+          </a:ln>
+          <a:effectLst/>
+        </p:spPr>
+        <p:style>
+          <a:lnRef idx="1">
+            <a:schemeClr val="accent1"/>
+          </a:lnRef>
+          <a:fillRef idx="3">
+            <a:schemeClr val="accent1"/>
+          </a:fillRef>
+          <a:effectRef idx="2">
+            <a:schemeClr val="accent1"/>
+          </a:effectRef>
+          <a:fontRef idx="minor">
+            <a:schemeClr val="lt1"/>
+          </a:fontRef>
+        </p:style>
+        <p:txBody>
+          <a:bodyPr rtlCol="0" anchor="ctr"/>
+          <a:lstStyle/>
+          <a:p>
+            <a:pPr algn="ctr"/>
+          </a:p>
+        </p:txBody>
+      </p:sp>
+      <p:sp>
+        <p:nvSpPr>
+          <p:cNvPr id="20" name="TextBox 19"/>
           <p:cNvSpPr txBox="1"/>
           <p:nvPr/>
         </p:nvSpPr>
@@ -16712,7 +17284,7 @@
       </p:sp>
       <p:sp>
         <p:nvSpPr>
-          <p:cNvPr id="20" name="TextBox 19"/>
+          <p:cNvPr id="21" name="TextBox 20"/>
           <p:cNvSpPr txBox="1"/>
           <p:nvPr/>
         </p:nvSpPr>
@@ -16751,7 +17323,51 @@
       </p:sp>
       <p:sp>
         <p:nvSpPr>
-          <p:cNvPr id="21" name="TextBox 20"/>
+          <p:cNvPr id="22" name="Rectangle 21"/>
+          <p:cNvSpPr/>
+          <p:nvPr/>
+        </p:nvSpPr>
+        <p:spPr>
+          <a:xfrm>
+            <a:off x="320040" y="4855464"/>
+            <a:ext cx="11521440" cy="886968"/>
+          </a:xfrm>
+          <a:prstGeom prst="rect">
+            <a:avLst/>
+          </a:prstGeom>
+          <a:solidFill>
+            <a:srgbClr val="16292B"/>
+          </a:solidFill>
+          <a:ln>
+            <a:noFill/>
+          </a:ln>
+          <a:effectLst/>
+        </p:spPr>
+        <p:style>
+          <a:lnRef idx="1">
+            <a:schemeClr val="accent1"/>
+          </a:lnRef>
+          <a:fillRef idx="3">
+            <a:schemeClr val="accent1"/>
+          </a:fillRef>
+          <a:effectRef idx="2">
+            <a:schemeClr val="accent1"/>
+          </a:effectRef>
+          <a:fontRef idx="minor">
+            <a:schemeClr val="lt1"/>
+          </a:fontRef>
+        </p:style>
+        <p:txBody>
+          <a:bodyPr rtlCol="0" anchor="ctr"/>
+          <a:lstStyle/>
+          <a:p>
+            <a:pPr algn="ctr"/>
+          </a:p>
+        </p:txBody>
+      </p:sp>
+      <p:sp>
+        <p:nvSpPr>
+          <p:cNvPr id="23" name="TextBox 22"/>
           <p:cNvSpPr txBox="1"/>
           <p:nvPr/>
         </p:nvSpPr>
@@ -16790,7 +17406,7 @@
       </p:sp>
       <p:sp>
         <p:nvSpPr>
-          <p:cNvPr id="22" name="TextBox 21"/>
+          <p:cNvPr id="24" name="TextBox 23"/>
           <p:cNvSpPr txBox="1"/>
           <p:nvPr/>
         </p:nvSpPr>
@@ -16829,7 +17445,7 @@
       </p:sp>
       <p:sp>
         <p:nvSpPr>
-          <p:cNvPr id="23" name="TextBox 22"/>
+          <p:cNvPr id="25" name="TextBox 24"/>
           <p:cNvSpPr txBox="1"/>
           <p:nvPr/>
         </p:nvSpPr>
@@ -16868,7 +17484,7 @@
       </p:sp>
       <p:sp>
         <p:nvSpPr>
-          <p:cNvPr id="24" name="TextBox 23"/>
+          <p:cNvPr id="26" name="TextBox 25"/>
           <p:cNvSpPr txBox="1"/>
           <p:nvPr/>
         </p:nvSpPr>
@@ -17770,7 +18386,51 @@
       </p:sp>
       <p:sp>
         <p:nvSpPr>
-          <p:cNvPr id="19" name="TextBox 18"/>
+          <p:cNvPr id="19" name="Rectangle 18"/>
+          <p:cNvSpPr/>
+          <p:nvPr/>
+        </p:nvSpPr>
+        <p:spPr>
+          <a:xfrm>
+            <a:off x="320040" y="4654296"/>
+            <a:ext cx="11521440" cy="640080"/>
+          </a:xfrm>
+          <a:prstGeom prst="rect">
+            <a:avLst/>
+          </a:prstGeom>
+          <a:solidFill>
+            <a:srgbClr val="2B2416"/>
+          </a:solidFill>
+          <a:ln>
+            <a:noFill/>
+          </a:ln>
+          <a:effectLst/>
+        </p:spPr>
+        <p:style>
+          <a:lnRef idx="1">
+            <a:schemeClr val="accent1"/>
+          </a:lnRef>
+          <a:fillRef idx="3">
+            <a:schemeClr val="accent1"/>
+          </a:fillRef>
+          <a:effectRef idx="2">
+            <a:schemeClr val="accent1"/>
+          </a:effectRef>
+          <a:fontRef idx="minor">
+            <a:schemeClr val="lt1"/>
+          </a:fontRef>
+        </p:style>
+        <p:txBody>
+          <a:bodyPr rtlCol="0" anchor="ctr"/>
+          <a:lstStyle/>
+          <a:p>
+            <a:pPr algn="ctr"/>
+          </a:p>
+        </p:txBody>
+      </p:sp>
+      <p:sp>
+        <p:nvSpPr>
+          <p:cNvPr id="20" name="TextBox 19"/>
           <p:cNvSpPr txBox="1"/>
           <p:nvPr/>
         </p:nvSpPr>
@@ -17809,7 +18469,7 @@
       </p:sp>
       <p:sp>
         <p:nvSpPr>
-          <p:cNvPr id="20" name="TextBox 19"/>
+          <p:cNvPr id="21" name="TextBox 20"/>
           <p:cNvSpPr txBox="1"/>
           <p:nvPr/>
         </p:nvSpPr>
@@ -17848,7 +18508,51 @@
       </p:sp>
       <p:sp>
         <p:nvSpPr>
-          <p:cNvPr id="21" name="TextBox 20"/>
+          <p:cNvPr id="22" name="Rectangle 21"/>
+          <p:cNvSpPr/>
+          <p:nvPr/>
+        </p:nvSpPr>
+        <p:spPr>
+          <a:xfrm>
+            <a:off x="320040" y="5349240"/>
+            <a:ext cx="11521440" cy="886968"/>
+          </a:xfrm>
+          <a:prstGeom prst="rect">
+            <a:avLst/>
+          </a:prstGeom>
+          <a:solidFill>
+            <a:srgbClr val="16292B"/>
+          </a:solidFill>
+          <a:ln>
+            <a:noFill/>
+          </a:ln>
+          <a:effectLst/>
+        </p:spPr>
+        <p:style>
+          <a:lnRef idx="1">
+            <a:schemeClr val="accent1"/>
+          </a:lnRef>
+          <a:fillRef idx="3">
+            <a:schemeClr val="accent1"/>
+          </a:fillRef>
+          <a:effectRef idx="2">
+            <a:schemeClr val="accent1"/>
+          </a:effectRef>
+          <a:fontRef idx="minor">
+            <a:schemeClr val="lt1"/>
+          </a:fontRef>
+        </p:style>
+        <p:txBody>
+          <a:bodyPr rtlCol="0" anchor="ctr"/>
+          <a:lstStyle/>
+          <a:p>
+            <a:pPr algn="ctr"/>
+          </a:p>
+        </p:txBody>
+      </p:sp>
+      <p:sp>
+        <p:nvSpPr>
+          <p:cNvPr id="23" name="TextBox 22"/>
           <p:cNvSpPr txBox="1"/>
           <p:nvPr/>
         </p:nvSpPr>
@@ -17887,7 +18591,7 @@
       </p:sp>
       <p:sp>
         <p:nvSpPr>
-          <p:cNvPr id="22" name="TextBox 21"/>
+          <p:cNvPr id="24" name="TextBox 23"/>
           <p:cNvSpPr txBox="1"/>
           <p:nvPr/>
         </p:nvSpPr>
@@ -17926,7 +18630,7 @@
       </p:sp>
       <p:sp>
         <p:nvSpPr>
-          <p:cNvPr id="23" name="TextBox 22"/>
+          <p:cNvPr id="25" name="TextBox 24"/>
           <p:cNvSpPr txBox="1"/>
           <p:nvPr/>
         </p:nvSpPr>
@@ -17965,7 +18669,7 @@
       </p:sp>
       <p:sp>
         <p:nvSpPr>
-          <p:cNvPr id="24" name="TextBox 23"/>
+          <p:cNvPr id="26" name="TextBox 25"/>
           <p:cNvSpPr txBox="1"/>
           <p:nvPr/>
         </p:nvSpPr>
@@ -18981,7 +19685,51 @@
       </p:sp>
       <p:sp>
         <p:nvSpPr>
-          <p:cNvPr id="18" name="TextBox 17"/>
+          <p:cNvPr id="18" name="Rectangle 17"/>
+          <p:cNvSpPr/>
+          <p:nvPr/>
+        </p:nvSpPr>
+        <p:spPr>
+          <a:xfrm>
+            <a:off x="320040" y="4800600"/>
+            <a:ext cx="11521440" cy="603504"/>
+          </a:xfrm>
+          <a:prstGeom prst="rect">
+            <a:avLst/>
+          </a:prstGeom>
+          <a:solidFill>
+            <a:srgbClr val="2B2416"/>
+          </a:solidFill>
+          <a:ln>
+            <a:noFill/>
+          </a:ln>
+          <a:effectLst/>
+        </p:spPr>
+        <p:style>
+          <a:lnRef idx="1">
+            <a:schemeClr val="accent1"/>
+          </a:lnRef>
+          <a:fillRef idx="3">
+            <a:schemeClr val="accent1"/>
+          </a:fillRef>
+          <a:effectRef idx="2">
+            <a:schemeClr val="accent1"/>
+          </a:effectRef>
+          <a:fontRef idx="minor">
+            <a:schemeClr val="lt1"/>
+          </a:fontRef>
+        </p:style>
+        <p:txBody>
+          <a:bodyPr rtlCol="0" anchor="ctr"/>
+          <a:lstStyle/>
+          <a:p>
+            <a:pPr algn="ctr"/>
+          </a:p>
+        </p:txBody>
+      </p:sp>
+      <p:sp>
+        <p:nvSpPr>
+          <p:cNvPr id="19" name="TextBox 18"/>
           <p:cNvSpPr txBox="1"/>
           <p:nvPr/>
         </p:nvSpPr>
@@ -19020,7 +19768,7 @@
       </p:sp>
       <p:sp>
         <p:nvSpPr>
-          <p:cNvPr id="19" name="TextBox 18"/>
+          <p:cNvPr id="20" name="TextBox 19"/>
           <p:cNvSpPr txBox="1"/>
           <p:nvPr/>
         </p:nvSpPr>
@@ -19077,7 +19825,51 @@
       </p:sp>
       <p:sp>
         <p:nvSpPr>
-          <p:cNvPr id="20" name="TextBox 19"/>
+          <p:cNvPr id="21" name="Rectangle 20"/>
+          <p:cNvSpPr/>
+          <p:nvPr/>
+        </p:nvSpPr>
+        <p:spPr>
+          <a:xfrm>
+            <a:off x="320040" y="5458968"/>
+            <a:ext cx="11521440" cy="832104"/>
+          </a:xfrm>
+          <a:prstGeom prst="rect">
+            <a:avLst/>
+          </a:prstGeom>
+          <a:solidFill>
+            <a:srgbClr val="16292B"/>
+          </a:solidFill>
+          <a:ln>
+            <a:noFill/>
+          </a:ln>
+          <a:effectLst/>
+        </p:spPr>
+        <p:style>
+          <a:lnRef idx="1">
+            <a:schemeClr val="accent1"/>
+          </a:lnRef>
+          <a:fillRef idx="3">
+            <a:schemeClr val="accent1"/>
+          </a:fillRef>
+          <a:effectRef idx="2">
+            <a:schemeClr val="accent1"/>
+          </a:effectRef>
+          <a:fontRef idx="minor">
+            <a:schemeClr val="lt1"/>
+          </a:fontRef>
+        </p:style>
+        <p:txBody>
+          <a:bodyPr rtlCol="0" anchor="ctr"/>
+          <a:lstStyle/>
+          <a:p>
+            <a:pPr algn="ctr"/>
+          </a:p>
+        </p:txBody>
+      </p:sp>
+      <p:sp>
+        <p:nvSpPr>
+          <p:cNvPr id="22" name="TextBox 21"/>
           <p:cNvSpPr txBox="1"/>
           <p:nvPr/>
         </p:nvSpPr>
@@ -19116,7 +19908,7 @@
       </p:sp>
       <p:sp>
         <p:nvSpPr>
-          <p:cNvPr id="21" name="TextBox 20"/>
+          <p:cNvPr id="23" name="TextBox 22"/>
           <p:cNvSpPr txBox="1"/>
           <p:nvPr/>
         </p:nvSpPr>
@@ -19227,7 +20019,7 @@
       </p:sp>
       <p:sp>
         <p:nvSpPr>
-          <p:cNvPr id="22" name="TextBox 21"/>
+          <p:cNvPr id="24" name="TextBox 23"/>
           <p:cNvSpPr txBox="1"/>
           <p:nvPr/>
         </p:nvSpPr>
@@ -19266,7 +20058,7 @@
       </p:sp>
       <p:sp>
         <p:nvSpPr>
-          <p:cNvPr id="23" name="TextBox 22"/>
+          <p:cNvPr id="25" name="TextBox 24"/>
           <p:cNvSpPr txBox="1"/>
           <p:nvPr/>
         </p:nvSpPr>
@@ -20126,7 +20918,7 @@
                 </a:solidFill>
                 <a:latin typeface="Noto Sans TC"/>
               </a:rPr>
-              <a:t>站台長這樣：待複判清單</a:t>
+              <a:t>待複判清單：作業員的第一頁</a:t>
             </a:r>
           </a:p>
         </p:txBody>
@@ -20332,7 +21124,7 @@
                 </a:solidFill>
                 <a:latin typeface="Noto Sans TC"/>
               </a:rPr>
-              <a:t>站台長這樣：一個區域怎麼判</a:t>
+              <a:t>區域頁：一個判定的全部證據</a:t>
             </a:r>
           </a:p>
         </p:txBody>
@@ -21187,7 +21979,51 @@
       </p:sp>
       <p:sp>
         <p:nvSpPr>
-          <p:cNvPr id="18" name="TextBox 17"/>
+          <p:cNvPr id="18" name="Rectangle 17"/>
+          <p:cNvSpPr/>
+          <p:nvPr/>
+        </p:nvSpPr>
+        <p:spPr>
+          <a:xfrm>
+            <a:off x="320040" y="4471416"/>
+            <a:ext cx="11521440" cy="640080"/>
+          </a:xfrm>
+          <a:prstGeom prst="rect">
+            <a:avLst/>
+          </a:prstGeom>
+          <a:solidFill>
+            <a:srgbClr val="2B2416"/>
+          </a:solidFill>
+          <a:ln>
+            <a:noFill/>
+          </a:ln>
+          <a:effectLst/>
+        </p:spPr>
+        <p:style>
+          <a:lnRef idx="1">
+            <a:schemeClr val="accent1"/>
+          </a:lnRef>
+          <a:fillRef idx="3">
+            <a:schemeClr val="accent1"/>
+          </a:fillRef>
+          <a:effectRef idx="2">
+            <a:schemeClr val="accent1"/>
+          </a:effectRef>
+          <a:fontRef idx="minor">
+            <a:schemeClr val="lt1"/>
+          </a:fontRef>
+        </p:style>
+        <p:txBody>
+          <a:bodyPr rtlCol="0" anchor="ctr"/>
+          <a:lstStyle/>
+          <a:p>
+            <a:pPr algn="ctr"/>
+          </a:p>
+        </p:txBody>
+      </p:sp>
+      <p:sp>
+        <p:nvSpPr>
+          <p:cNvPr id="19" name="TextBox 18"/>
           <p:cNvSpPr txBox="1"/>
           <p:nvPr/>
         </p:nvSpPr>
@@ -21226,7 +22062,7 @@
       </p:sp>
       <p:sp>
         <p:nvSpPr>
-          <p:cNvPr id="19" name="TextBox 18"/>
+          <p:cNvPr id="20" name="TextBox 19"/>
           <p:cNvSpPr txBox="1"/>
           <p:nvPr/>
         </p:nvSpPr>
@@ -21265,7 +22101,51 @@
       </p:sp>
       <p:sp>
         <p:nvSpPr>
-          <p:cNvPr id="20" name="TextBox 19"/>
+          <p:cNvPr id="21" name="Rectangle 20"/>
+          <p:cNvSpPr/>
+          <p:nvPr/>
+        </p:nvSpPr>
+        <p:spPr>
+          <a:xfrm>
+            <a:off x="320040" y="5166360"/>
+            <a:ext cx="11521440" cy="886968"/>
+          </a:xfrm>
+          <a:prstGeom prst="rect">
+            <a:avLst/>
+          </a:prstGeom>
+          <a:solidFill>
+            <a:srgbClr val="16292B"/>
+          </a:solidFill>
+          <a:ln>
+            <a:noFill/>
+          </a:ln>
+          <a:effectLst/>
+        </p:spPr>
+        <p:style>
+          <a:lnRef idx="1">
+            <a:schemeClr val="accent1"/>
+          </a:lnRef>
+          <a:fillRef idx="3">
+            <a:schemeClr val="accent1"/>
+          </a:fillRef>
+          <a:effectRef idx="2">
+            <a:schemeClr val="accent1"/>
+          </a:effectRef>
+          <a:fontRef idx="minor">
+            <a:schemeClr val="lt1"/>
+          </a:fontRef>
+        </p:style>
+        <p:txBody>
+          <a:bodyPr rtlCol="0" anchor="ctr"/>
+          <a:lstStyle/>
+          <a:p>
+            <a:pPr algn="ctr"/>
+          </a:p>
+        </p:txBody>
+      </p:sp>
+      <p:sp>
+        <p:nvSpPr>
+          <p:cNvPr id="22" name="TextBox 21"/>
           <p:cNvSpPr txBox="1"/>
           <p:nvPr/>
         </p:nvSpPr>
@@ -21304,7 +22184,7 @@
       </p:sp>
       <p:sp>
         <p:nvSpPr>
-          <p:cNvPr id="21" name="TextBox 20"/>
+          <p:cNvPr id="23" name="TextBox 22"/>
           <p:cNvSpPr txBox="1"/>
           <p:nvPr/>
         </p:nvSpPr>
@@ -21361,7 +22241,7 @@
       </p:sp>
       <p:sp>
         <p:nvSpPr>
-          <p:cNvPr id="22" name="TextBox 21"/>
+          <p:cNvPr id="24" name="TextBox 23"/>
           <p:cNvSpPr txBox="1"/>
           <p:nvPr/>
         </p:nvSpPr>
@@ -21400,7 +22280,7 @@
       </p:sp>
       <p:sp>
         <p:nvSpPr>
-          <p:cNvPr id="23" name="TextBox 22"/>
+          <p:cNvPr id="25" name="TextBox 24"/>
           <p:cNvSpPr txBox="1"/>
           <p:nvPr/>
         </p:nvSpPr>
@@ -21876,7 +22756,7 @@
                 </a:solidFill>
                 <a:latin typeface="Noto Sans TC"/>
               </a:rPr>
-              <a:t>站台長這樣：主管問一句話</a:t>
+              <a:t>產線查詢：一句話到一張有區間的圖</a:t>
             </a:r>
           </a:p>
         </p:txBody>
@@ -22965,7 +23845,51 @@
       </p:sp>
       <p:sp>
         <p:nvSpPr>
-          <p:cNvPr id="18" name="TextBox 17"/>
+          <p:cNvPr id="18" name="Rectangle 17"/>
+          <p:cNvSpPr/>
+          <p:nvPr/>
+        </p:nvSpPr>
+        <p:spPr>
+          <a:xfrm>
+            <a:off x="320040" y="4718304"/>
+            <a:ext cx="11521440" cy="393192"/>
+          </a:xfrm>
+          <a:prstGeom prst="rect">
+            <a:avLst/>
+          </a:prstGeom>
+          <a:solidFill>
+            <a:srgbClr val="2B2416"/>
+          </a:solidFill>
+          <a:ln>
+            <a:noFill/>
+          </a:ln>
+          <a:effectLst/>
+        </p:spPr>
+        <p:style>
+          <a:lnRef idx="1">
+            <a:schemeClr val="accent1"/>
+          </a:lnRef>
+          <a:fillRef idx="3">
+            <a:schemeClr val="accent1"/>
+          </a:fillRef>
+          <a:effectRef idx="2">
+            <a:schemeClr val="accent1"/>
+          </a:effectRef>
+          <a:fontRef idx="minor">
+            <a:schemeClr val="lt1"/>
+          </a:fontRef>
+        </p:style>
+        <p:txBody>
+          <a:bodyPr rtlCol="0" anchor="ctr"/>
+          <a:lstStyle/>
+          <a:p>
+            <a:pPr algn="ctr"/>
+          </a:p>
+        </p:txBody>
+      </p:sp>
+      <p:sp>
+        <p:nvSpPr>
+          <p:cNvPr id="19" name="TextBox 18"/>
           <p:cNvSpPr txBox="1"/>
           <p:nvPr/>
         </p:nvSpPr>
@@ -23004,7 +23928,7 @@
       </p:sp>
       <p:sp>
         <p:nvSpPr>
-          <p:cNvPr id="19" name="TextBox 18"/>
+          <p:cNvPr id="20" name="TextBox 19"/>
           <p:cNvSpPr txBox="1"/>
           <p:nvPr/>
         </p:nvSpPr>
@@ -23061,7 +23985,51 @@
       </p:sp>
       <p:sp>
         <p:nvSpPr>
-          <p:cNvPr id="20" name="TextBox 19"/>
+          <p:cNvPr id="21" name="Rectangle 20"/>
+          <p:cNvSpPr/>
+          <p:nvPr/>
+        </p:nvSpPr>
+        <p:spPr>
+          <a:xfrm>
+            <a:off x="320040" y="5166360"/>
+            <a:ext cx="11521440" cy="640080"/>
+          </a:xfrm>
+          <a:prstGeom prst="rect">
+            <a:avLst/>
+          </a:prstGeom>
+          <a:solidFill>
+            <a:srgbClr val="16292B"/>
+          </a:solidFill>
+          <a:ln>
+            <a:noFill/>
+          </a:ln>
+          <a:effectLst/>
+        </p:spPr>
+        <p:style>
+          <a:lnRef idx="1">
+            <a:schemeClr val="accent1"/>
+          </a:lnRef>
+          <a:fillRef idx="3">
+            <a:schemeClr val="accent1"/>
+          </a:fillRef>
+          <a:effectRef idx="2">
+            <a:schemeClr val="accent1"/>
+          </a:effectRef>
+          <a:fontRef idx="minor">
+            <a:schemeClr val="lt1"/>
+          </a:fontRef>
+        </p:style>
+        <p:txBody>
+          <a:bodyPr rtlCol="0" anchor="ctr"/>
+          <a:lstStyle/>
+          <a:p>
+            <a:pPr algn="ctr"/>
+          </a:p>
+        </p:txBody>
+      </p:sp>
+      <p:sp>
+        <p:nvSpPr>
+          <p:cNvPr id="22" name="TextBox 21"/>
           <p:cNvSpPr txBox="1"/>
           <p:nvPr/>
         </p:nvSpPr>
@@ -23100,7 +24068,7 @@
       </p:sp>
       <p:sp>
         <p:nvSpPr>
-          <p:cNvPr id="21" name="TextBox 20"/>
+          <p:cNvPr id="23" name="TextBox 22"/>
           <p:cNvSpPr txBox="1"/>
           <p:nvPr/>
         </p:nvSpPr>
@@ -23193,7 +24161,7 @@
       </p:sp>
       <p:sp>
         <p:nvSpPr>
-          <p:cNvPr id="22" name="TextBox 21"/>
+          <p:cNvPr id="24" name="TextBox 23"/>
           <p:cNvSpPr txBox="1"/>
           <p:nvPr/>
         </p:nvSpPr>
@@ -23232,7 +24200,7 @@
       </p:sp>
       <p:sp>
         <p:nvSpPr>
-          <p:cNvPr id="23" name="TextBox 22"/>
+          <p:cNvPr id="25" name="TextBox 24"/>
           <p:cNvSpPr txBox="1"/>
           <p:nvPr/>
         </p:nvSpPr>
@@ -24158,7 +25126,51 @@
       </p:sp>
       <p:sp>
         <p:nvSpPr>
-          <p:cNvPr id="18" name="TextBox 17"/>
+          <p:cNvPr id="18" name="Rectangle 17"/>
+          <p:cNvSpPr/>
+          <p:nvPr/>
+        </p:nvSpPr>
+        <p:spPr>
+          <a:xfrm>
+            <a:off x="320040" y="4572000"/>
+            <a:ext cx="11521440" cy="832104"/>
+          </a:xfrm>
+          <a:prstGeom prst="rect">
+            <a:avLst/>
+          </a:prstGeom>
+          <a:solidFill>
+            <a:srgbClr val="2B2416"/>
+          </a:solidFill>
+          <a:ln>
+            <a:noFill/>
+          </a:ln>
+          <a:effectLst/>
+        </p:spPr>
+        <p:style>
+          <a:lnRef idx="1">
+            <a:schemeClr val="accent1"/>
+          </a:lnRef>
+          <a:fillRef idx="3">
+            <a:schemeClr val="accent1"/>
+          </a:fillRef>
+          <a:effectRef idx="2">
+            <a:schemeClr val="accent1"/>
+          </a:effectRef>
+          <a:fontRef idx="minor">
+            <a:schemeClr val="lt1"/>
+          </a:fontRef>
+        </p:style>
+        <p:txBody>
+          <a:bodyPr rtlCol="0" anchor="ctr"/>
+          <a:lstStyle/>
+          <a:p>
+            <a:pPr algn="ctr"/>
+          </a:p>
+        </p:txBody>
+      </p:sp>
+      <p:sp>
+        <p:nvSpPr>
+          <p:cNvPr id="19" name="TextBox 18"/>
           <p:cNvSpPr txBox="1"/>
           <p:nvPr/>
         </p:nvSpPr>
@@ -24197,7 +25209,7 @@
       </p:sp>
       <p:sp>
         <p:nvSpPr>
-          <p:cNvPr id="19" name="TextBox 18"/>
+          <p:cNvPr id="20" name="TextBox 19"/>
           <p:cNvSpPr txBox="1"/>
           <p:nvPr/>
         </p:nvSpPr>
@@ -24236,7 +25248,51 @@
       </p:sp>
       <p:sp>
         <p:nvSpPr>
-          <p:cNvPr id="20" name="TextBox 19"/>
+          <p:cNvPr id="21" name="Rectangle 20"/>
+          <p:cNvSpPr/>
+          <p:nvPr/>
+        </p:nvSpPr>
+        <p:spPr>
+          <a:xfrm>
+            <a:off x="320040" y="5458968"/>
+            <a:ext cx="11521440" cy="832104"/>
+          </a:xfrm>
+          <a:prstGeom prst="rect">
+            <a:avLst/>
+          </a:prstGeom>
+          <a:solidFill>
+            <a:srgbClr val="16292B"/>
+          </a:solidFill>
+          <a:ln>
+            <a:noFill/>
+          </a:ln>
+          <a:effectLst/>
+        </p:spPr>
+        <p:style>
+          <a:lnRef idx="1">
+            <a:schemeClr val="accent1"/>
+          </a:lnRef>
+          <a:fillRef idx="3">
+            <a:schemeClr val="accent1"/>
+          </a:fillRef>
+          <a:effectRef idx="2">
+            <a:schemeClr val="accent1"/>
+          </a:effectRef>
+          <a:fontRef idx="minor">
+            <a:schemeClr val="lt1"/>
+          </a:fontRef>
+        </p:style>
+        <p:txBody>
+          <a:bodyPr rtlCol="0" anchor="ctr"/>
+          <a:lstStyle/>
+          <a:p>
+            <a:pPr algn="ctr"/>
+          </a:p>
+        </p:txBody>
+      </p:sp>
+      <p:sp>
+        <p:nvSpPr>
+          <p:cNvPr id="22" name="TextBox 21"/>
           <p:cNvSpPr txBox="1"/>
           <p:nvPr/>
         </p:nvSpPr>
@@ -24275,7 +25331,7 @@
       </p:sp>
       <p:sp>
         <p:nvSpPr>
-          <p:cNvPr id="21" name="TextBox 20"/>
+          <p:cNvPr id="23" name="TextBox 22"/>
           <p:cNvSpPr txBox="1"/>
           <p:nvPr/>
         </p:nvSpPr>
@@ -24332,7 +25388,7 @@
       </p:sp>
       <p:sp>
         <p:nvSpPr>
-          <p:cNvPr id="22" name="TextBox 21"/>
+          <p:cNvPr id="24" name="TextBox 23"/>
           <p:cNvSpPr txBox="1"/>
           <p:nvPr/>
         </p:nvSpPr>
@@ -24371,7 +25427,7 @@
       </p:sp>
       <p:sp>
         <p:nvSpPr>
-          <p:cNvPr id="23" name="TextBox 22"/>
+          <p:cNvPr id="25" name="TextBox 24"/>
           <p:cNvSpPr txBox="1"/>
           <p:nvPr/>
         </p:nvSpPr>
@@ -25318,7 +26374,51 @@
       </p:sp>
       <p:sp>
         <p:nvSpPr>
-          <p:cNvPr id="19" name="TextBox 18"/>
+          <p:cNvPr id="19" name="Rectangle 18"/>
+          <p:cNvSpPr/>
+          <p:nvPr/>
+        </p:nvSpPr>
+        <p:spPr>
+          <a:xfrm>
+            <a:off x="320040" y="4654296"/>
+            <a:ext cx="11521440" cy="640080"/>
+          </a:xfrm>
+          <a:prstGeom prst="rect">
+            <a:avLst/>
+          </a:prstGeom>
+          <a:solidFill>
+            <a:srgbClr val="2B2416"/>
+          </a:solidFill>
+          <a:ln>
+            <a:noFill/>
+          </a:ln>
+          <a:effectLst/>
+        </p:spPr>
+        <p:style>
+          <a:lnRef idx="1">
+            <a:schemeClr val="accent1"/>
+          </a:lnRef>
+          <a:fillRef idx="3">
+            <a:schemeClr val="accent1"/>
+          </a:fillRef>
+          <a:effectRef idx="2">
+            <a:schemeClr val="accent1"/>
+          </a:effectRef>
+          <a:fontRef idx="minor">
+            <a:schemeClr val="lt1"/>
+          </a:fontRef>
+        </p:style>
+        <p:txBody>
+          <a:bodyPr rtlCol="0" anchor="ctr"/>
+          <a:lstStyle/>
+          <a:p>
+            <a:pPr algn="ctr"/>
+          </a:p>
+        </p:txBody>
+      </p:sp>
+      <p:sp>
+        <p:nvSpPr>
+          <p:cNvPr id="20" name="TextBox 19"/>
           <p:cNvSpPr txBox="1"/>
           <p:nvPr/>
         </p:nvSpPr>
@@ -25357,7 +26457,7 @@
       </p:sp>
       <p:sp>
         <p:nvSpPr>
-          <p:cNvPr id="20" name="TextBox 19"/>
+          <p:cNvPr id="21" name="TextBox 20"/>
           <p:cNvSpPr txBox="1"/>
           <p:nvPr/>
         </p:nvSpPr>
@@ -25396,7 +26496,51 @@
       </p:sp>
       <p:sp>
         <p:nvSpPr>
-          <p:cNvPr id="21" name="TextBox 20"/>
+          <p:cNvPr id="22" name="Rectangle 21"/>
+          <p:cNvSpPr/>
+          <p:nvPr/>
+        </p:nvSpPr>
+        <p:spPr>
+          <a:xfrm>
+            <a:off x="320040" y="5349240"/>
+            <a:ext cx="11521440" cy="886968"/>
+          </a:xfrm>
+          <a:prstGeom prst="rect">
+            <a:avLst/>
+          </a:prstGeom>
+          <a:solidFill>
+            <a:srgbClr val="16292B"/>
+          </a:solidFill>
+          <a:ln>
+            <a:noFill/>
+          </a:ln>
+          <a:effectLst/>
+        </p:spPr>
+        <p:style>
+          <a:lnRef idx="1">
+            <a:schemeClr val="accent1"/>
+          </a:lnRef>
+          <a:fillRef idx="3">
+            <a:schemeClr val="accent1"/>
+          </a:fillRef>
+          <a:effectRef idx="2">
+            <a:schemeClr val="accent1"/>
+          </a:effectRef>
+          <a:fontRef idx="minor">
+            <a:schemeClr val="lt1"/>
+          </a:fontRef>
+        </p:style>
+        <p:txBody>
+          <a:bodyPr rtlCol="0" anchor="ctr"/>
+          <a:lstStyle/>
+          <a:p>
+            <a:pPr algn="ctr"/>
+          </a:p>
+        </p:txBody>
+      </p:sp>
+      <p:sp>
+        <p:nvSpPr>
+          <p:cNvPr id="23" name="TextBox 22"/>
           <p:cNvSpPr txBox="1"/>
           <p:nvPr/>
         </p:nvSpPr>
@@ -25435,7 +26579,7 @@
       </p:sp>
       <p:sp>
         <p:nvSpPr>
-          <p:cNvPr id="22" name="TextBox 21"/>
+          <p:cNvPr id="24" name="TextBox 23"/>
           <p:cNvSpPr txBox="1"/>
           <p:nvPr/>
         </p:nvSpPr>
@@ -25474,7 +26618,7 @@
       </p:sp>
       <p:sp>
         <p:nvSpPr>
-          <p:cNvPr id="23" name="TextBox 22"/>
+          <p:cNvPr id="25" name="TextBox 24"/>
           <p:cNvSpPr txBox="1"/>
           <p:nvPr/>
         </p:nvSpPr>
@@ -25513,7 +26657,7 @@
       </p:sp>
       <p:sp>
         <p:nvSpPr>
-          <p:cNvPr id="24" name="TextBox 23"/>
+          <p:cNvPr id="26" name="TextBox 25"/>
           <p:cNvSpPr txBox="1"/>
           <p:nvPr/>
         </p:nvSpPr>
@@ -26352,7 +27496,51 @@
       </p:sp>
       <p:sp>
         <p:nvSpPr>
-          <p:cNvPr id="19" name="TextBox 18"/>
+          <p:cNvPr id="19" name="Rectangle 18"/>
+          <p:cNvSpPr/>
+          <p:nvPr/>
+        </p:nvSpPr>
+        <p:spPr>
+          <a:xfrm>
+            <a:off x="320040" y="5148072"/>
+            <a:ext cx="11521440" cy="393192"/>
+          </a:xfrm>
+          <a:prstGeom prst="rect">
+            <a:avLst/>
+          </a:prstGeom>
+          <a:solidFill>
+            <a:srgbClr val="2B2416"/>
+          </a:solidFill>
+          <a:ln>
+            <a:noFill/>
+          </a:ln>
+          <a:effectLst/>
+        </p:spPr>
+        <p:style>
+          <a:lnRef idx="1">
+            <a:schemeClr val="accent1"/>
+          </a:lnRef>
+          <a:fillRef idx="3">
+            <a:schemeClr val="accent1"/>
+          </a:fillRef>
+          <a:effectRef idx="2">
+            <a:schemeClr val="accent1"/>
+          </a:effectRef>
+          <a:fontRef idx="minor">
+            <a:schemeClr val="lt1"/>
+          </a:fontRef>
+        </p:style>
+        <p:txBody>
+          <a:bodyPr rtlCol="0" anchor="ctr"/>
+          <a:lstStyle/>
+          <a:p>
+            <a:pPr algn="ctr"/>
+          </a:p>
+        </p:txBody>
+      </p:sp>
+      <p:sp>
+        <p:nvSpPr>
+          <p:cNvPr id="20" name="TextBox 19"/>
           <p:cNvSpPr txBox="1"/>
           <p:nvPr/>
         </p:nvSpPr>
@@ -26391,7 +27579,7 @@
       </p:sp>
       <p:sp>
         <p:nvSpPr>
-          <p:cNvPr id="20" name="TextBox 19"/>
+          <p:cNvPr id="21" name="TextBox 20"/>
           <p:cNvSpPr txBox="1"/>
           <p:nvPr/>
         </p:nvSpPr>
@@ -26430,7 +27618,51 @@
       </p:sp>
       <p:sp>
         <p:nvSpPr>
-          <p:cNvPr id="21" name="TextBox 20"/>
+          <p:cNvPr id="22" name="Rectangle 21"/>
+          <p:cNvSpPr/>
+          <p:nvPr/>
+        </p:nvSpPr>
+        <p:spPr>
+          <a:xfrm>
+            <a:off x="320040" y="5596128"/>
+            <a:ext cx="11521440" cy="640080"/>
+          </a:xfrm>
+          <a:prstGeom prst="rect">
+            <a:avLst/>
+          </a:prstGeom>
+          <a:solidFill>
+            <a:srgbClr val="16292B"/>
+          </a:solidFill>
+          <a:ln>
+            <a:noFill/>
+          </a:ln>
+          <a:effectLst/>
+        </p:spPr>
+        <p:style>
+          <a:lnRef idx="1">
+            <a:schemeClr val="accent1"/>
+          </a:lnRef>
+          <a:fillRef idx="3">
+            <a:schemeClr val="accent1"/>
+          </a:fillRef>
+          <a:effectRef idx="2">
+            <a:schemeClr val="accent1"/>
+          </a:effectRef>
+          <a:fontRef idx="minor">
+            <a:schemeClr val="lt1"/>
+          </a:fontRef>
+        </p:style>
+        <p:txBody>
+          <a:bodyPr rtlCol="0" anchor="ctr"/>
+          <a:lstStyle/>
+          <a:p>
+            <a:pPr algn="ctr"/>
+          </a:p>
+        </p:txBody>
+      </p:sp>
+      <p:sp>
+        <p:nvSpPr>
+          <p:cNvPr id="23" name="TextBox 22"/>
           <p:cNvSpPr txBox="1"/>
           <p:nvPr/>
         </p:nvSpPr>
@@ -26469,7 +27701,7 @@
       </p:sp>
       <p:sp>
         <p:nvSpPr>
-          <p:cNvPr id="22" name="TextBox 21"/>
+          <p:cNvPr id="24" name="TextBox 23"/>
           <p:cNvSpPr txBox="1"/>
           <p:nvPr/>
         </p:nvSpPr>
@@ -26562,7 +27794,7 @@
       </p:sp>
       <p:sp>
         <p:nvSpPr>
-          <p:cNvPr id="23" name="TextBox 22"/>
+          <p:cNvPr id="25" name="TextBox 24"/>
           <p:cNvSpPr txBox="1"/>
           <p:nvPr/>
         </p:nvSpPr>
@@ -26601,7 +27833,7 @@
       </p:sp>
       <p:sp>
         <p:nvSpPr>
-          <p:cNvPr id="24" name="TextBox 23"/>
+          <p:cNvPr id="26" name="TextBox 25"/>
           <p:cNvSpPr txBox="1"/>
           <p:nvPr/>
         </p:nvSpPr>
@@ -34842,7 +36074,51 @@
       </p:sp>
       <p:sp>
         <p:nvSpPr>
-          <p:cNvPr id="18" name="TextBox 17"/>
+          <p:cNvPr id="18" name="Rectangle 17"/>
+          <p:cNvSpPr/>
+          <p:nvPr/>
+        </p:nvSpPr>
+        <p:spPr>
+          <a:xfrm>
+            <a:off x="320040" y="4443984"/>
+            <a:ext cx="11521440" cy="713232"/>
+          </a:xfrm>
+          <a:prstGeom prst="rect">
+            <a:avLst/>
+          </a:prstGeom>
+          <a:solidFill>
+            <a:srgbClr val="2B2416"/>
+          </a:solidFill>
+          <a:ln>
+            <a:noFill/>
+          </a:ln>
+          <a:effectLst/>
+        </p:spPr>
+        <p:style>
+          <a:lnRef idx="1">
+            <a:schemeClr val="accent1"/>
+          </a:lnRef>
+          <a:fillRef idx="3">
+            <a:schemeClr val="accent1"/>
+          </a:fillRef>
+          <a:effectRef idx="2">
+            <a:schemeClr val="accent1"/>
+          </a:effectRef>
+          <a:fontRef idx="minor">
+            <a:schemeClr val="lt1"/>
+          </a:fontRef>
+        </p:style>
+        <p:txBody>
+          <a:bodyPr rtlCol="0" anchor="ctr"/>
+          <a:lstStyle/>
+          <a:p>
+            <a:pPr algn="ctr"/>
+          </a:p>
+        </p:txBody>
+      </p:sp>
+      <p:sp>
+        <p:nvSpPr>
+          <p:cNvPr id="19" name="TextBox 18"/>
           <p:cNvSpPr txBox="1"/>
           <p:nvPr/>
         </p:nvSpPr>
@@ -34881,7 +36157,7 @@
       </p:sp>
       <p:sp>
         <p:nvSpPr>
-          <p:cNvPr id="19" name="TextBox 18"/>
+          <p:cNvPr id="20" name="TextBox 19"/>
           <p:cNvSpPr txBox="1"/>
           <p:nvPr/>
         </p:nvSpPr>
@@ -34974,7 +36250,51 @@
       </p:sp>
       <p:sp>
         <p:nvSpPr>
-          <p:cNvPr id="20" name="TextBox 19"/>
+          <p:cNvPr id="21" name="Rectangle 20"/>
+          <p:cNvSpPr/>
+          <p:nvPr/>
+        </p:nvSpPr>
+        <p:spPr>
+          <a:xfrm>
+            <a:off x="320040" y="5212080"/>
+            <a:ext cx="11521440" cy="429768"/>
+          </a:xfrm>
+          <a:prstGeom prst="rect">
+            <a:avLst/>
+          </a:prstGeom>
+          <a:solidFill>
+            <a:srgbClr val="16292B"/>
+          </a:solidFill>
+          <a:ln>
+            <a:noFill/>
+          </a:ln>
+          <a:effectLst/>
+        </p:spPr>
+        <p:style>
+          <a:lnRef idx="1">
+            <a:schemeClr val="accent1"/>
+          </a:lnRef>
+          <a:fillRef idx="3">
+            <a:schemeClr val="accent1"/>
+          </a:fillRef>
+          <a:effectRef idx="2">
+            <a:schemeClr val="accent1"/>
+          </a:effectRef>
+          <a:fontRef idx="minor">
+            <a:schemeClr val="lt1"/>
+          </a:fontRef>
+        </p:style>
+        <p:txBody>
+          <a:bodyPr rtlCol="0" anchor="ctr"/>
+          <a:lstStyle/>
+          <a:p>
+            <a:pPr algn="ctr"/>
+          </a:p>
+        </p:txBody>
+      </p:sp>
+      <p:sp>
+        <p:nvSpPr>
+          <p:cNvPr id="22" name="TextBox 21"/>
           <p:cNvSpPr txBox="1"/>
           <p:nvPr/>
         </p:nvSpPr>
@@ -35013,7 +36333,7 @@
       </p:sp>
       <p:sp>
         <p:nvSpPr>
-          <p:cNvPr id="21" name="TextBox 20"/>
+          <p:cNvPr id="23" name="TextBox 22"/>
           <p:cNvSpPr txBox="1"/>
           <p:nvPr/>
         </p:nvSpPr>
@@ -35052,7 +36372,7 @@
       </p:sp>
       <p:sp>
         <p:nvSpPr>
-          <p:cNvPr id="22" name="TextBox 21"/>
+          <p:cNvPr id="24" name="TextBox 23"/>
           <p:cNvSpPr txBox="1"/>
           <p:nvPr/>
         </p:nvSpPr>
@@ -35091,7 +36411,7 @@
       </p:sp>
       <p:sp>
         <p:nvSpPr>
-          <p:cNvPr id="23" name="TextBox 22"/>
+          <p:cNvPr id="25" name="TextBox 24"/>
           <p:cNvSpPr txBox="1"/>
           <p:nvPr/>
         </p:nvSpPr>
@@ -36056,7 +37376,51 @@
       </p:sp>
       <p:sp>
         <p:nvSpPr>
-          <p:cNvPr id="19" name="TextBox 18"/>
+          <p:cNvPr id="19" name="Rectangle 18"/>
+          <p:cNvSpPr/>
+          <p:nvPr/>
+        </p:nvSpPr>
+        <p:spPr>
+          <a:xfrm>
+            <a:off x="320040" y="4517133"/>
+            <a:ext cx="11521440" cy="411480"/>
+          </a:xfrm>
+          <a:prstGeom prst="rect">
+            <a:avLst/>
+          </a:prstGeom>
+          <a:solidFill>
+            <a:srgbClr val="2B2416"/>
+          </a:solidFill>
+          <a:ln>
+            <a:noFill/>
+          </a:ln>
+          <a:effectLst/>
+        </p:spPr>
+        <p:style>
+          <a:lnRef idx="1">
+            <a:schemeClr val="accent1"/>
+          </a:lnRef>
+          <a:fillRef idx="3">
+            <a:schemeClr val="accent1"/>
+          </a:fillRef>
+          <a:effectRef idx="2">
+            <a:schemeClr val="accent1"/>
+          </a:effectRef>
+          <a:fontRef idx="minor">
+            <a:schemeClr val="lt1"/>
+          </a:fontRef>
+        </p:style>
+        <p:txBody>
+          <a:bodyPr rtlCol="0" anchor="ctr"/>
+          <a:lstStyle/>
+          <a:p>
+            <a:pPr algn="ctr"/>
+          </a:p>
+        </p:txBody>
+      </p:sp>
+      <p:sp>
+        <p:nvSpPr>
+          <p:cNvPr id="20" name="TextBox 19"/>
           <p:cNvSpPr txBox="1"/>
           <p:nvPr/>
         </p:nvSpPr>
@@ -36095,7 +37459,7 @@
       </p:sp>
       <p:sp>
         <p:nvSpPr>
-          <p:cNvPr id="20" name="TextBox 19"/>
+          <p:cNvPr id="21" name="TextBox 20"/>
           <p:cNvSpPr txBox="1"/>
           <p:nvPr/>
         </p:nvSpPr>
@@ -36134,7 +37498,51 @@
       </p:sp>
       <p:sp>
         <p:nvSpPr>
-          <p:cNvPr id="21" name="TextBox 20"/>
+          <p:cNvPr id="22" name="Rectangle 21"/>
+          <p:cNvSpPr/>
+          <p:nvPr/>
+        </p:nvSpPr>
+        <p:spPr>
+          <a:xfrm>
+            <a:off x="320040" y="4983477"/>
+            <a:ext cx="11521440" cy="941831"/>
+          </a:xfrm>
+          <a:prstGeom prst="rect">
+            <a:avLst/>
+          </a:prstGeom>
+          <a:solidFill>
+            <a:srgbClr val="16292B"/>
+          </a:solidFill>
+          <a:ln>
+            <a:noFill/>
+          </a:ln>
+          <a:effectLst/>
+        </p:spPr>
+        <p:style>
+          <a:lnRef idx="1">
+            <a:schemeClr val="accent1"/>
+          </a:lnRef>
+          <a:fillRef idx="3">
+            <a:schemeClr val="accent1"/>
+          </a:fillRef>
+          <a:effectRef idx="2">
+            <a:schemeClr val="accent1"/>
+          </a:effectRef>
+          <a:fontRef idx="minor">
+            <a:schemeClr val="lt1"/>
+          </a:fontRef>
+        </p:style>
+        <p:txBody>
+          <a:bodyPr rtlCol="0" anchor="ctr"/>
+          <a:lstStyle/>
+          <a:p>
+            <a:pPr algn="ctr"/>
+          </a:p>
+        </p:txBody>
+      </p:sp>
+      <p:sp>
+        <p:nvSpPr>
+          <p:cNvPr id="23" name="TextBox 22"/>
           <p:cNvSpPr txBox="1"/>
           <p:nvPr/>
         </p:nvSpPr>
@@ -36173,7 +37581,7 @@
       </p:sp>
       <p:sp>
         <p:nvSpPr>
-          <p:cNvPr id="22" name="TextBox 21"/>
+          <p:cNvPr id="24" name="TextBox 23"/>
           <p:cNvSpPr txBox="1"/>
           <p:nvPr/>
         </p:nvSpPr>
@@ -36248,7 +37656,7 @@
       </p:sp>
       <p:sp>
         <p:nvSpPr>
-          <p:cNvPr id="23" name="TextBox 22"/>
+          <p:cNvPr id="25" name="TextBox 24"/>
           <p:cNvSpPr txBox="1"/>
           <p:nvPr/>
         </p:nvSpPr>
@@ -36287,7 +37695,7 @@
       </p:sp>
       <p:sp>
         <p:nvSpPr>
-          <p:cNvPr id="24" name="TextBox 23"/>
+          <p:cNvPr id="26" name="TextBox 25"/>
           <p:cNvSpPr txBox="1"/>
           <p:nvPr/>
         </p:nvSpPr>
@@ -37141,7 +38549,51 @@
       </p:sp>
       <p:sp>
         <p:nvSpPr>
-          <p:cNvPr id="18" name="TextBox 17"/>
+          <p:cNvPr id="18" name="Rectangle 17"/>
+          <p:cNvSpPr/>
+          <p:nvPr/>
+        </p:nvSpPr>
+        <p:spPr>
+          <a:xfrm>
+            <a:off x="320040" y="4471416"/>
+            <a:ext cx="11521440" cy="886968"/>
+          </a:xfrm>
+          <a:prstGeom prst="rect">
+            <a:avLst/>
+          </a:prstGeom>
+          <a:solidFill>
+            <a:srgbClr val="2B2416"/>
+          </a:solidFill>
+          <a:ln>
+            <a:noFill/>
+          </a:ln>
+          <a:effectLst/>
+        </p:spPr>
+        <p:style>
+          <a:lnRef idx="1">
+            <a:schemeClr val="accent1"/>
+          </a:lnRef>
+          <a:fillRef idx="3">
+            <a:schemeClr val="accent1"/>
+          </a:fillRef>
+          <a:effectRef idx="2">
+            <a:schemeClr val="accent1"/>
+          </a:effectRef>
+          <a:fontRef idx="minor">
+            <a:schemeClr val="lt1"/>
+          </a:fontRef>
+        </p:style>
+        <p:txBody>
+          <a:bodyPr rtlCol="0" anchor="ctr"/>
+          <a:lstStyle/>
+          <a:p>
+            <a:pPr algn="ctr"/>
+          </a:p>
+        </p:txBody>
+      </p:sp>
+      <p:sp>
+        <p:nvSpPr>
+          <p:cNvPr id="19" name="TextBox 18"/>
           <p:cNvSpPr txBox="1"/>
           <p:nvPr/>
         </p:nvSpPr>
@@ -37180,7 +38632,7 @@
       </p:sp>
       <p:sp>
         <p:nvSpPr>
-          <p:cNvPr id="19" name="TextBox 18"/>
+          <p:cNvPr id="20" name="TextBox 19"/>
           <p:cNvSpPr txBox="1"/>
           <p:nvPr/>
         </p:nvSpPr>
@@ -37309,7 +38761,51 @@
       </p:sp>
       <p:sp>
         <p:nvSpPr>
-          <p:cNvPr id="20" name="TextBox 19"/>
+          <p:cNvPr id="21" name="Rectangle 20"/>
+          <p:cNvSpPr/>
+          <p:nvPr/>
+        </p:nvSpPr>
+        <p:spPr>
+          <a:xfrm>
+            <a:off x="320040" y="5413248"/>
+            <a:ext cx="11521440" cy="640080"/>
+          </a:xfrm>
+          <a:prstGeom prst="rect">
+            <a:avLst/>
+          </a:prstGeom>
+          <a:solidFill>
+            <a:srgbClr val="16292B"/>
+          </a:solidFill>
+          <a:ln>
+            <a:noFill/>
+          </a:ln>
+          <a:effectLst/>
+        </p:spPr>
+        <p:style>
+          <a:lnRef idx="1">
+            <a:schemeClr val="accent1"/>
+          </a:lnRef>
+          <a:fillRef idx="3">
+            <a:schemeClr val="accent1"/>
+          </a:fillRef>
+          <a:effectRef idx="2">
+            <a:schemeClr val="accent1"/>
+          </a:effectRef>
+          <a:fontRef idx="minor">
+            <a:schemeClr val="lt1"/>
+          </a:fontRef>
+        </p:style>
+        <p:txBody>
+          <a:bodyPr rtlCol="0" anchor="ctr"/>
+          <a:lstStyle/>
+          <a:p>
+            <a:pPr algn="ctr"/>
+          </a:p>
+        </p:txBody>
+      </p:sp>
+      <p:sp>
+        <p:nvSpPr>
+          <p:cNvPr id="22" name="TextBox 21"/>
           <p:cNvSpPr txBox="1"/>
           <p:nvPr/>
         </p:nvSpPr>
@@ -37348,7 +38844,7 @@
       </p:sp>
       <p:sp>
         <p:nvSpPr>
-          <p:cNvPr id="21" name="TextBox 20"/>
+          <p:cNvPr id="23" name="TextBox 22"/>
           <p:cNvSpPr txBox="1"/>
           <p:nvPr/>
         </p:nvSpPr>
@@ -37405,7 +38901,7 @@
       </p:sp>
       <p:sp>
         <p:nvSpPr>
-          <p:cNvPr id="22" name="TextBox 21"/>
+          <p:cNvPr id="24" name="TextBox 23"/>
           <p:cNvSpPr txBox="1"/>
           <p:nvPr/>
         </p:nvSpPr>
@@ -37444,7 +38940,7 @@
       </p:sp>
       <p:sp>
         <p:nvSpPr>
-          <p:cNvPr id="23" name="TextBox 22"/>
+          <p:cNvPr id="25" name="TextBox 24"/>
           <p:cNvSpPr txBox="1"/>
           <p:nvPr/>
         </p:nvSpPr>

</xml_diff>

<commit_message>
The three station screenshots are cut where the page says, not where the window ends
A 1440x900 browser window on a 16:9 slide is limited by height, so its
text landed at a third of its size and the table was clipped mid-row.
They are taken at 1200 css px now and cut at a boundary the DOM defines
-- the end of the second queue row, the triptych element, the chart
element -- which gives bands of 2.0 to 2.7:1 that the slide shows at
full width. scripts/deck_screenshots.py is how they are re-taken.

Co-Authored-By: Claude Fable 5 <noreply@anthropic.com>
</commit_message>
<xml_diff>
--- a/docs/deck/aoi-agent-journey.zh-TW.pptx
+++ b/docs/deck/aoi-agent-journey.zh-TW.pptx
@@ -20939,8 +20939,8 @@
         </p:blipFill>
         <p:spPr>
           <a:xfrm>
-            <a:off x="2218791" y="1005840"/>
-            <a:ext cx="7754112" cy="4846320"/>
+            <a:off x="1265628" y="1005840"/>
+            <a:ext cx="9660438" cy="4846320"/>
           </a:xfrm>
           <a:prstGeom prst="rect">
             <a:avLst/>
@@ -21145,8 +21145,8 @@
         </p:blipFill>
         <p:spPr>
           <a:xfrm>
-            <a:off x="2218791" y="1005840"/>
-            <a:ext cx="7754112" cy="4846320"/>
+            <a:off x="380847" y="1005840"/>
+            <a:ext cx="11430000" cy="4216797"/>
           </a:xfrm>
           <a:prstGeom prst="rect">
             <a:avLst/>
@@ -22777,8 +22777,8 @@
         </p:blipFill>
         <p:spPr>
           <a:xfrm>
-            <a:off x="2218791" y="1005840"/>
-            <a:ext cx="7754112" cy="4846320"/>
+            <a:off x="380847" y="1005840"/>
+            <a:ext cx="11430000" cy="4667423"/>
           </a:xfrm>
           <a:prstGeom prst="rect">
             <a:avLst/>

</xml_diff>

<commit_message>
The operating-point slide's script now opens with what the escape rate is, because "is it important" is the question and "it is the budget" is the answer
The notes described the curve and then listed the caveats. Asked the question
cold -- is the escape rate important in this system -- the answer is not a
caveat list: it is that the escape rate is not one metric among several but
the constraint every other number is quoted underneath, which is also why no
headline here is an accuracy.

Five spoken sentences in that order: the asymmetric cost and why not accuracy,
where 0.961 came from, then the three things worth saying before being asked --
the interval that does not exclude the budget, the class the average hides and
why no cut on the model's own output reaches it, and that the escape rate
transfers between lines while the review reduction does not. Two questions to
match, and a bullet pointing at the 0.22% the threshold cannot touch.
</commit_message>
<xml_diff>
--- a/docs/deck/aoi-agent-journey.zh-TW.pptx
+++ b/docs/deck/aoi-agent-journey.zh-TW.pptx
@@ -766,22 +766,27 @@
           <a:p/>
           <a:p>
             <a:r>
-              <a:t>講稿 1. 這是頭條的那張曲線。橫軸漏網率、縱軸省掉的人工，門檻掃過去就是這條線。</a:t>
-            </a:r>
-          </a:p>
-          <a:p>
-            <a:r>
-              <a:t>講稿 2. 選 0.961 是因為它是漏網率不超過 0.5% 的最低門檻，這個數字來自掃描，不是手調。</a:t>
-            </a:r>
-          </a:p>
-          <a:p>
-            <a:r>
-              <a:t>講稿 3. 但平均數不能單獨報：分類別看，short 漏 1.55%，是平均的三倍，而 short 是規範裡一個都不准放的類別。</a:t>
-            </a:r>
-          </a:p>
-          <a:p>
-            <a:r>
-              <a:t>講稿 4. 這些漏掉的是模型很有信心的錯，不是猶豫的錯，所以模型自己救不了，要電測。</a:t>
+              <a:t>講稿 1. 先講這張圖在回答什麼：漏檢率在這個系統裡不是一個指標，是一個預算。代價不對稱——漏一片是那片板子出貨了，多報一次是作業員三秒——所以我從來不報準確率，準確率把這兩種錯當成一樣重。</a:t>
+            </a:r>
+          </a:p>
+          <a:p>
+            <a:r>
+              <a:t>講稿 2. 橫軸漏檢率、縱軸省掉的人工，門檻掃過去就是這條線。我選 0.961，因為它是漏檢率不超過千分之五的最低門檻，這個數字從掃描來，不是手調的。</a:t>
+            </a:r>
+          </a:p>
+          <a:p>
+            <a:r>
+              <a:t>講稿 3. 接下來三件事我自己講，不等人問。第一，0.5% 是這個測試集上的點估計：15 個漏檢除以 3,018 個缺陷，95% 區間到 0.82%，不排除超預算。</a:t>
+            </a:r>
+          </a:p>
+          <a:p>
+            <a:r>
+              <a:t>講稿 4. 第二，平均值蓋掉了一個類別：short 漏 1.55%，是預算的三倍，而規範對 short 是零容忍；而且這些是有信心的錯，模型給它們的分數只有 0.00007 到 0.00589，門檻切不開，要靠電測這個不共用同一種失敗的第二次量測。</a:t>
+            </a:r>
+          </a:p>
+          <a:p>
+            <a:r>
+              <a:t>講稿 5. 第三，漏檢率跟不良率無關，換一條線照樣成立；會變的是省人工那個數字，線越乾淨越高，0.5% 不良率時是 89.0%——所以我報 52.8% 的時候一定會把它假設的 41.2% 不良率一起講。</a:t>
             </a:r>
           </a:p>
           <a:p/>
@@ -790,6 +795,28 @@
               <a:t>面試官會問：</a:t>
             </a:r>
           </a:p>
+          <a:p>
+            <a:r>
+              <a:t>Q：漏檢率重要嗎？為什麼不報準確率？</a:t>
+            </a:r>
+          </a:p>
+          <a:p>
+            <a:r>
+              <a:t>A：它不是重要的指標之一，它是預算——其他每個數字都是在它固定之後才有意義。代價不對稱：漏一片是出貨，多報一次是三秒。準確率把這兩種錯當成一樣重，所以整條產線的取捨在那個數字上是看不見的。</a:t>
+            </a:r>
+          </a:p>
+          <a:p/>
+          <a:p>
+            <a:r>
+              <a:t>Q：換一條產線，這些數字還成立嗎？</a:t>
+            </a:r>
+          </a:p>
+          <a:p>
+            <a:r>
+              <a:t>A：漏檢率成立，省人工不成立。漏檢率除以缺陷總數，不良率重新加權會約掉；52.8% 假設的是這個 split 的 41.2% 不良率，線越乾淨越高——0.5% 不良率時是 89.0%。真正不能轉移的是驗證：一條只看到 100 個缺陷的試產線，確認不了 0.5% 的預算。</a:t>
+            </a:r>
+          </a:p>
+          <a:p/>
           <a:p>
             <a:r>
               <a:t>Q：為什麼不對 short 單獨設更嚴的門檻？</a:t>
@@ -10376,6 +10403,57 @@
                 <a:cs typeface="Noto Sans TC"/>
               </a:rPr>
               <a:t> 本來就寫了。</a:t>
+            </a:r>
+          </a:p>
+          <a:p>
+            <a:pPr>
+              <a:lnSpc>
+                <a:spcPct val="125000"/>
+              </a:lnSpc>
+            </a:pPr>
+            <a:r>
+              <a:rPr sz="1300" b="0">
+                <a:solidFill>
+                  <a:srgbClr val="6FC7CF"/>
+                </a:solidFill>
+                <a:latin typeface="Noto Sans TC"/>
+                <a:ea typeface="Noto Sans TC"/>
+                <a:cs typeface="Noto Sans TC"/>
+              </a:rPr>
+              <a:t>• </a:t>
+            </a:r>
+            <a:r>
+              <a:rPr sz="1300" b="0">
+                <a:solidFill>
+                  <a:srgbClr val="E8E6E1"/>
+                </a:solidFill>
+                <a:latin typeface="Noto Sans TC"/>
+                <a:ea typeface="Noto Sans TC"/>
+                <a:cs typeface="Noto Sans TC"/>
+              </a:rPr>
+              <a:t>漏檢還有第二個來源，在這條線之外：</a:t>
+            </a:r>
+            <a:r>
+              <a:rPr sz="1300" b="1">
+                <a:solidFill>
+                  <a:srgbClr val="6FC7CF"/>
+                </a:solidFill>
+                <a:latin typeface="Noto Sans TC"/>
+                <a:ea typeface="Noto Sans TC"/>
+                <a:cs typeface="Noto Sans TC"/>
+              </a:rPr>
+              <a:t>0.22%</a:t>
+            </a:r>
+            <a:r>
+              <a:rPr sz="1300" b="0">
+                <a:solidFill>
+                  <a:srgbClr val="E8E6E1"/>
+                </a:solidFill>
+                <a:latin typeface="Noto Sans TC"/>
+                <a:ea typeface="Noto Sans TC"/>
+                <a:cs typeface="Noto Sans TC"/>
+              </a:rPr>
+              <a:t> 的缺陷 AOI 根本沒框到，門檻碰不到（上一層那頁）</a:t>
             </a:r>
           </a:p>
         </p:txBody>

</xml_diff>

<commit_message>
The "I never ran the control" sentence is now false, so it comes out of the deck
Appendix B measured four ways of doing this job with one ruler; the ablation is
a fifth read with the same ruler, so it belongs in that table rather than
somewhere new -- random initialisation at 42.32% sits between the template
channel and the floor. Two lines change with it: the floor row said "about 1%",
which is the 0.25% budget's reading, and the slide's own question already said
1.3%; and a bullet now names the 1.5-point accuracy gap next to the 10-point
operating-point gap, because a reader comparing accuracy would conclude the
initialisation barely matters.

Co-Authored-By: Claude Opus 5 <noreply@anthropic.com>
</commit_message>
<xml_diff>
--- a/docs/deck/aoi-agent-journey.zh-TW.pptx
+++ b/docs/deck/aoi-agent-journey.zh-TW.pptx
@@ -4324,28 +4324,28 @@
           <a:lstStyle/>
           <a:p>
             <a:r>
-              <a:t>白話：同一把尺（≤0.5% 漏網下省掉多少）量四種做法，只有帶樣板通道的小 CNN 站得住。</a:t>
+              <a:t>白話：同一把尺（≤0.5% 漏網下省掉多少）量五種做法。輸入裡有沒有樣板、起點是不是預訓練的，比網路多大重要得多。</a:t>
             </a:r>
           </a:p>
           <a:p/>
           <a:p>
             <a:r>
-              <a:t>講稿 1. 「為什麼是 ResNet-18」的答案在這張表：同一把尺量四種做法。</a:t>
-            </a:r>
-          </a:p>
-          <a:p>
-            <a:r>
-              <a:t>講稿 2. 先看地板：不用模型、只算差異圖的統計，大約 1%。模型 52.8%，40 倍。</a:t>
-            </a:r>
-          </a:p>
-          <a:p>
-            <a:r>
-              <a:t>講稿 3. 再看兩個對照：拿掉樣板通道剩 2.8%，偵測器的信心 1.2%。所以關鍵不是網路多大，是輸入裡有沒有「本來該長怎樣」。</a:t>
-            </a:r>
-          </a:p>
-          <a:p>
-            <a:r>
-              <a:t>講稿 4. 沒試更大的模型，因為剩下的漏網是很有信心的錯，不是容量問題。</a:t>
+              <a:t>講稿 1. 「為什麼是這個模型」的答案在這張表：同一把尺量五種做法，沒有一種是換更大的網路。</a:t>
+            </a:r>
+          </a:p>
+          <a:p>
+            <a:r>
+              <a:t>講稿 2. 先看地板：不用模型、只算差異圖的統計，1.3%。模型 52.8%，四十倍。</a:t>
+            </a:r>
+          </a:p>
+          <a:p>
+            <a:r>
+              <a:t>講稿 3. 中間三列各拿掉一樣東西：拿掉 ImageNet 起點剩 42.3%，拿掉樣板通道剩 2.8%，整條換成偵測器的信心 1.2%。</a:t>
+            </a:r>
+          </a:p>
+          <a:p>
+            <a:r>
+              <a:t>講稿 4. 所以關鍵不是網路多大，是輸入裡有沒有「本來該長怎樣」、起點裡有沒有現成的特徵。剩下的漏網是很有信心的錯，那不是容量問題。</a:t>
             </a:r>
           </a:p>
           <a:p/>
@@ -4372,7 +4372,18 @@
           </a:p>
           <a:p>
             <a:r>
-              <a:t>A：差異圖上不用模型就能算的分數：平均值、最大值、前 32/64/128 個像素的和、超過某亮度的像素數，各自當 P(false call) 掃同一條曲線，最好的在 ≤0.5% 下是 1.3%。</a:t>
+              <a:t>A：差異圖上不用模型就能算的分數：平均值、最大值、前 32/64/128 個像素的和、超過某亮度的像素數，各自當 P(false call) 掃同一條曲線，最好的在 ≤0.5% 下是 1.3%。還放了一個沒有訊號的常數分數當對照組，省 0.0%——證明那個 1.3% 不是掃描自己變出來的。</a:t>
+            </a:r>
+          </a:p>
+          <a:p/>
+          <a:p>
+            <a:r>
+              <a:t>Q：二值化的板子差異圖跟 ImageNet 一點都不像，預訓練憑什麼有用？</a:t>
+            </a:r>
+          </a:p>
+          <a:p>
+            <a:r>
+              <a:t>A：我也這樣懷疑，所以量了。三個 seed、每個 seed 內兩邊用同一份切分，ImageNet 贏 6.71 / 18.07 / 10.46 分，全同方向；尺是「什麼都不改」的 seed 離散度 3.1 分。而且它買到的不只是分數：隨機起點那邊三個 seed 跨 8.7 分，ImageNet 那邊只跨 3.1，重訓一次會跳多少差三倍。</a:t>
             </a:r>
           </a:p>
         </p:txBody>
@@ -35734,7 +35745,7 @@
                 <a:ea typeface="Noto Sans TC"/>
                 <a:cs typeface="Noto Sans TC"/>
               </a:rPr>
-              <a:t>附錄 B · 為什麼是這個模型：四個對照</a:t>
+              <a:t>附錄 B · 為什麼是這個模型：五個對照</a:t>
             </a:r>
           </a:p>
         </p:txBody>
@@ -35749,7 +35760,7 @@
         </p:nvGraphicFramePr>
         <p:xfrm>
           <a:off x="548640" y="1280160"/>
-          <a:ext cx="11064240" cy="2286000"/>
+          <a:ext cx="11064240" cy="2743200"/>
         </p:xfrm>
         <a:graphic>
           <a:graphicData uri="http://schemas.openxmlformats.org/drawingml/2006/table">
@@ -35875,7 +35886,7 @@
                           <a:ea typeface="Noto Sans TC"/>
                           <a:cs typeface="Noto Sans TC"/>
                         </a:rPr>
-                        <a:t>約 1%</a:t>
+                        <a:t>1.3%</a:t>
                       </a:r>
                     </a:p>
                   </a:txBody>
@@ -35999,7 +36010,7 @@
                           <a:ea typeface="Noto Sans TC"/>
                           <a:cs typeface="Noto Sans TC"/>
                         </a:rPr>
-                        <a:t>同一個 ResNet-18，沒有樣板通道（偵測器 crop）</a:t>
+                        <a:t>同一個 ResNet-18，隨機初始化</a:t>
                       </a:r>
                     </a:p>
                   </a:txBody>
@@ -36023,7 +36034,7 @@
                           <a:ea typeface="Noto Sans TC"/>
                           <a:cs typeface="Noto Sans TC"/>
                         </a:rPr>
-                        <a:t>2.8%</a:t>
+                        <a:t>42.32%</a:t>
                       </a:r>
                     </a:p>
                   </a:txBody>
@@ -36047,7 +36058,7 @@
                           <a:ea typeface="Noto Sans TC"/>
                           <a:cs typeface="Noto Sans TC"/>
                         </a:rPr>
-                        <a:t>外觀本身分不開真假；樣板通道是必要不是方便</a:t>
+                        <a:t>同一份切分內配對、三個 seed 全同方向；免費的 ImageNet 起點值 10 分</a:t>
                       </a:r>
                     </a:p>
                   </a:txBody>
@@ -36073,7 +36084,7 @@
                           <a:ea typeface="Noto Sans TC"/>
                           <a:cs typeface="Noto Sans TC"/>
                         </a:rPr>
-                        <a:t>YOLO26n 的 confidence 直接排序</a:t>
+                        <a:t>同一個 ResNet-18，沒有樣板通道（偵測器 crop）</a:t>
                       </a:r>
                     </a:p>
                   </a:txBody>
@@ -36097,7 +36108,7 @@
                           <a:ea typeface="Noto Sans TC"/>
                           <a:cs typeface="Noto Sans TC"/>
                         </a:rPr>
-                        <a:t>1.2%</a:t>
+                        <a:t>2.8%</a:t>
                       </a:r>
                     </a:p>
                   </a:txBody>
@@ -36121,7 +36132,7 @@
                           <a:ea typeface="Noto Sans TC"/>
                           <a:cs typeface="Noto Sans TC"/>
                         </a:rPr>
-                        <a:t>偵測器的信心是「這裡有東西」的分數，不是 P(false call)</a:t>
+                        <a:t>外觀本身分不開真假；樣板通道是必要不是方便</a:t>
                       </a:r>
                     </a:p>
                   </a:txBody>
@@ -36132,6 +36143,80 @@
                   </a:tcPr>
                 </a:tc>
               </a:tr>
+              <a:tr h="457200">
+                <a:tc>
+                  <a:txBody>
+                    <a:bodyPr/>
+                    <a:lstStyle/>
+                    <a:p>
+                      <a:r>
+                        <a:rPr sz="1300" b="0">
+                          <a:solidFill>
+                            <a:srgbClr val="E8E6E1"/>
+                          </a:solidFill>
+                          <a:latin typeface="Noto Sans TC"/>
+                          <a:ea typeface="Noto Sans TC"/>
+                          <a:cs typeface="Noto Sans TC"/>
+                        </a:rPr>
+                        <a:t>YOLO26n 的 confidence 直接排序</a:t>
+                      </a:r>
+                    </a:p>
+                  </a:txBody>
+                  <a:tcPr marT="36576" marB="36576">
+                    <a:solidFill>
+                      <a:srgbClr val="1E2125"/>
+                    </a:solidFill>
+                  </a:tcPr>
+                </a:tc>
+                <a:tc>
+                  <a:txBody>
+                    <a:bodyPr/>
+                    <a:lstStyle/>
+                    <a:p>
+                      <a:r>
+                        <a:rPr sz="1300" b="0">
+                          <a:solidFill>
+                            <a:srgbClr val="E8E6E1"/>
+                          </a:solidFill>
+                          <a:latin typeface="Noto Sans TC"/>
+                          <a:ea typeface="Noto Sans TC"/>
+                          <a:cs typeface="Noto Sans TC"/>
+                        </a:rPr>
+                        <a:t>1.2%</a:t>
+                      </a:r>
+                    </a:p>
+                  </a:txBody>
+                  <a:tcPr marT="36576" marB="36576">
+                    <a:solidFill>
+                      <a:srgbClr val="1E2125"/>
+                    </a:solidFill>
+                  </a:tcPr>
+                </a:tc>
+                <a:tc>
+                  <a:txBody>
+                    <a:bodyPr/>
+                    <a:lstStyle/>
+                    <a:p>
+                      <a:r>
+                        <a:rPr sz="1300" b="0">
+                          <a:solidFill>
+                            <a:srgbClr val="E8E6E1"/>
+                          </a:solidFill>
+                          <a:latin typeface="Noto Sans TC"/>
+                          <a:ea typeface="Noto Sans TC"/>
+                          <a:cs typeface="Noto Sans TC"/>
+                        </a:rPr>
+                        <a:t>偵測器的信心是「這裡有東西」的分數，不是 P(false call)</a:t>
+                      </a:r>
+                    </a:p>
+                  </a:txBody>
+                  <a:tcPr marT="36576" marB="36576">
+                    <a:solidFill>
+                      <a:srgbClr val="1E2125"/>
+                    </a:solidFill>
+                  </a:tcPr>
+                </a:tc>
+              </a:tr>
             </a:tbl>
           </a:graphicData>
         </a:graphic>
@@ -36144,8 +36229,8 @@
         </p:nvSpPr>
         <p:spPr>
           <a:xfrm>
-            <a:off x="548640" y="3794760"/>
-            <a:ext cx="11064240" cy="2514600"/>
+            <a:off x="548640" y="4251960"/>
+            <a:ext cx="11064240" cy="2057400"/>
           </a:xfrm>
           <a:prstGeom prst="rect">
             <a:avLst/>
@@ -36228,6 +36313,123 @@
                 <a:cs typeface="Noto Sans TC"/>
               </a:rPr>
               <a:t> 只是一個量，不是證據</a:t>
+            </a:r>
+          </a:p>
+          <a:p>
+            <a:pPr>
+              <a:lnSpc>
+                <a:spcPct val="125000"/>
+              </a:lnSpc>
+            </a:pPr>
+            <a:r>
+              <a:rPr sz="1400" b="0">
+                <a:solidFill>
+                  <a:srgbClr val="6FC7CF"/>
+                </a:solidFill>
+                <a:latin typeface="Noto Sans TC"/>
+                <a:ea typeface="Noto Sans TC"/>
+                <a:cs typeface="Noto Sans TC"/>
+              </a:rPr>
+              <a:t>• </a:t>
+            </a:r>
+            <a:r>
+              <a:rPr sz="1400" b="0">
+                <a:solidFill>
+                  <a:srgbClr val="E8E6E1"/>
+                </a:solidFill>
+                <a:latin typeface="Noto Sans TC"/>
+                <a:ea typeface="Noto Sans TC"/>
+                <a:cs typeface="Noto Sans TC"/>
+              </a:rPr>
+              <a:t>預訓練那一列的準確率只差 </a:t>
+            </a:r>
+            <a:r>
+              <a:rPr sz="1400" b="1">
+                <a:solidFill>
+                  <a:srgbClr val="6FC7CF"/>
+                </a:solidFill>
+                <a:latin typeface="Noto Sans TC"/>
+                <a:ea typeface="Noto Sans TC"/>
+                <a:cs typeface="Noto Sans TC"/>
+              </a:rPr>
+              <a:t>1.5</a:t>
+            </a:r>
+            <a:r>
+              <a:rPr sz="1400" b="0">
+                <a:solidFill>
+                  <a:srgbClr val="E8E6E1"/>
+                </a:solidFill>
+                <a:latin typeface="Noto Sans TC"/>
+                <a:ea typeface="Noto Sans TC"/>
+                <a:cs typeface="Noto Sans TC"/>
+              </a:rPr>
+              <a:t> 分（</a:t>
+            </a:r>
+            <a:r>
+              <a:rPr sz="1400" b="1">
+                <a:solidFill>
+                  <a:srgbClr val="6FC7CF"/>
+                </a:solidFill>
+                <a:latin typeface="Noto Sans TC"/>
+                <a:ea typeface="Noto Sans TC"/>
+                <a:cs typeface="Noto Sans TC"/>
+              </a:rPr>
+              <a:t>96.4%</a:t>
+            </a:r>
+            <a:r>
+              <a:rPr sz="1400" b="0">
+                <a:solidFill>
+                  <a:srgbClr val="E8E6E1"/>
+                </a:solidFill>
+                <a:latin typeface="Noto Sans TC"/>
+                <a:ea typeface="Noto Sans TC"/>
+                <a:cs typeface="Noto Sans TC"/>
+              </a:rPr>
+              <a:t> 對 </a:t>
+            </a:r>
+            <a:r>
+              <a:rPr sz="1400" b="1">
+                <a:solidFill>
+                  <a:srgbClr val="6FC7CF"/>
+                </a:solidFill>
+                <a:latin typeface="Noto Sans TC"/>
+                <a:ea typeface="Noto Sans TC"/>
+                <a:cs typeface="Noto Sans TC"/>
+              </a:rPr>
+              <a:t>97.2–98.6%</a:t>
+            </a:r>
+            <a:r>
+              <a:rPr sz="1400" b="0">
+                <a:solidFill>
+                  <a:srgbClr val="E8E6E1"/>
+                </a:solidFill>
+                <a:latin typeface="Noto Sans TC"/>
+                <a:ea typeface="Noto Sans TC"/>
+                <a:cs typeface="Noto Sans TC"/>
+              </a:rPr>
+              <a:t>）而操作點差 </a:t>
+            </a:r>
+            <a:r>
+              <a:rPr sz="1400" b="1">
+                <a:solidFill>
+                  <a:srgbClr val="6FC7CF"/>
+                </a:solidFill>
+                <a:latin typeface="Noto Sans TC"/>
+                <a:ea typeface="Noto Sans TC"/>
+                <a:cs typeface="Noto Sans TC"/>
+              </a:rPr>
+              <a:t>10</a:t>
+            </a:r>
+            <a:r>
+              <a:rPr sz="1400" b="0">
+                <a:solidFill>
+                  <a:srgbClr val="E8E6E1"/>
+                </a:solidFill>
+                <a:latin typeface="Noto Sans TC"/>
+                <a:ea typeface="Noto Sans TC"/>
+                <a:cs typeface="Noto Sans TC"/>
+              </a:rPr>
+              <a:t> 分——只看準確率會下「沒差」的結論</a:t>
             </a:r>
           </a:p>
           <a:p>

</xml_diff>

<commit_message>
The deck's appendix B carried the strawman floor, so it carried the wrong ratio
Six comparisons now, with both floors in the table and the weak one labelled as
what it is. The 40x bullet is gone; the ratio a reader should quote is 3.1x. Two
questions added: what the two floors differ by, and which features the tree won
on -- and the threshold slide gains the one that matters most, that a model
sharing no weights with the ResNet hits the same trainval-to-test wall.

Co-Authored-By: Claude Opus 5 <noreply@anthropic.com>
</commit_message>
<xml_diff>
--- a/docs/deck/aoi-agent-journey.zh-TW.pptx
+++ b/docs/deck/aoi-agent-journey.zh-TW.pptx
@@ -1459,6 +1459,17 @@
               <a:t>A：以這個 checkpoint、這份資料，按候選算是不達標的。要達標有兩條路：一條是電測那類不共用同一種失敗的第二次量測，算出來 0.43%；另一條是讓選門檻的資料能代表出貨的資料，而那需要第二份資料集或真的產線，不是再調一次參數。</a:t>
             </a:r>
           </a:p>
+          <a:p/>
+          <a:p>
+            <a:r>
+              <a:t>Q：你怎麼確定那個兩倍是資料的問題，不是你的模型的問題？</a:t>
+            </a:r>
+          </a:p>
+          <a:p>
+            <a:r>
+              <a:t>A：09-01 用完全不同的方法量到同一件事。一棵梯度提升樹、30 個手工幾何特徵，跟 ResNet 不共用任何權重、架構或訓練流程——三個 seed 在 trainval 的驗證半邊都省 28.6 到 30.2%，在 test 上只有 15.9 到 21.3%，一樣是好一半。兩種方法碰到同一堵牆，那就不是模型的性質，是切分的性質。</a:t>
+            </a:r>
+          </a:p>
         </p:txBody>
       </p:sp>
       <p:sp>
@@ -4324,28 +4335,28 @@
           <a:lstStyle/>
           <a:p>
             <a:r>
-              <a:t>白話：同一把尺（≤0.5% 漏網下省掉多少）量五種做法。輸入裡有沒有樣板、起點是不是預訓練的，比網路多大重要得多。</a:t>
+              <a:t>白話：同一把尺（≤0.5% 漏網下省掉多少）量六種做法。輸入裡有沒有樣板、起點是不是預訓練的，比網路多大重要得多。</a:t>
             </a:r>
           </a:p>
           <a:p/>
           <a:p>
             <a:r>
-              <a:t>講稿 1. 「為什麼是這個模型」的答案在這張表：同一把尺量五種做法，沒有一種是換更大的網路。</a:t>
-            </a:r>
-          </a:p>
-          <a:p>
-            <a:r>
-              <a:t>講稿 2. 先看地板：不用模型、只算差異圖的統計，1.3%。模型 52.8%，四十倍。</a:t>
-            </a:r>
-          </a:p>
-          <a:p>
-            <a:r>
-              <a:t>講稿 3. 中間三列各拿掉一樣東西：拿掉 ImageNet 起點剩 42.3%，拿掉樣板通道剩 2.8%，整條換成偵測器的信心 1.2%。</a:t>
-            </a:r>
-          </a:p>
-          <a:p>
-            <a:r>
-              <a:t>講稿 4. 所以關鍵不是網路多大，是輸入裡有沒有「本來該長怎樣」、起點裡有沒有現成的特徵。剩下的漏網是很有信心的錯，那不是容量問題。</a:t>
+              <a:t>講稿 1. 「為什麼是這個模型」的答案在這張表：同一把尺量六種做法，沒有一種是換更大的網路。</a:t>
+            </a:r>
+          </a:p>
+          <a:p>
+            <a:r>
+              <a:t>講稿 2. 地板有兩個。弱的那個只算差異圖的統計，1.3%——但那是稻草人，候選本來就是靠差異大挑出來的。強的那個看形狀：30 個幾何特徵加一棵樹，16.70%。</a:t>
+            </a:r>
+          </a:p>
+          <a:p>
+            <a:r>
+              <a:t>講稿 3. 所以正確的講法是 3.1 倍，不是 40 倍。而網路贏的那 36 分是對一個站得住的對手贏的。</a:t>
+            </a:r>
+          </a:p>
+          <a:p>
+            <a:r>
+              <a:t>講稿 4. 剩下四列各拿掉一樣東西：拿掉 ImageNet 起點剩 42.3%，拿掉樣板通道剩 2.8%，整條換成偵測器的信心 1.2%。關鍵不是網路多大。</a:t>
             </a:r>
           </a:p>
           <a:p/>
@@ -4367,12 +4378,23 @@
           <a:p/>
           <a:p>
             <a:r>
-              <a:t>Q：地板是怎麼算的？</a:t>
-            </a:r>
-          </a:p>
-          <a:p>
-            <a:r>
-              <a:t>A：差異圖上不用模型就能算的分數：平均值、最大值、前 32/64/128 個像素的和、超過某亮度的像素數，各自當 P(false call) 掃同一條曲線，最好的在 ≤0.5% 下是 1.3%。還放了一個沒有訊號的常數分數當對照組，省 0.0%——證明那個 1.3% 不是掃描自己變出來的。</a:t>
+              <a:t>Q：地板是怎麼算的？兩個地板差在哪？</a:t>
+            </a:r>
+          </a:p>
+          <a:p>
+            <a:r>
+              <a:t>A：弱的那個是差異圖上不用模型就能算的純量——平均、最大、前 32/64/128 個像素的和——最好的在 ≤0.5% 下是 1.3%，另外放一個沒訊號的常數分數當對照組，省 0.0%。但它是稻草人：候選正是 AOI 靠「差異大」挑出來的，再拿差異量排序等於問一個上游已經答過的問題。強的那個補上它丟掉的東西——形狀：30 個幾何特徵加一棵梯度提升樹，16.70%（三個 seed 15.94 到 21.28）。所以我引用的倍率是 3.1 倍。</a:t>
+            </a:r>
+          </a:p>
+          <a:p/>
+          <a:p>
+            <a:r>
+              <a:t>Q：那棵樹是靠哪些特徵贏的？</a:t>
+            </a:r>
+          </a:p>
+          <a:p>
+            <a:r>
+              <a:t>A：三個 seed 的重要度前兩名都一樣：blob_distance_to_edge 和 elongation——差異塊離樣板邊緣多近、多長多細。那正是「誤報是對位殘差留在走線邊的細條、瑕疵是塊狀」這個假設，被量出來而不是被斷言。而我本來以為會最重要的那個（待測比樣板多銅還少銅）幾乎沒進榜——明顯有意義和在這裡有鑑別力是兩件事。</a:t>
             </a:r>
           </a:p>
           <a:p/>
@@ -35745,7 +35767,7 @@
                 <a:ea typeface="Noto Sans TC"/>
                 <a:cs typeface="Noto Sans TC"/>
               </a:rPr>
-              <a:t>附錄 B · 為什麼是這個模型：五個對照</a:t>
+              <a:t>附錄 B · 為什麼是這個模型：六個對照</a:t>
             </a:r>
           </a:p>
         </p:txBody>
@@ -35760,7 +35782,7 @@
         </p:nvGraphicFramePr>
         <p:xfrm>
           <a:off x="548640" y="1280160"/>
-          <a:ext cx="11064240" cy="2743200"/>
+          <a:ext cx="11064240" cy="3200400"/>
         </p:xfrm>
         <a:graphic>
           <a:graphicData uri="http://schemas.openxmlformats.org/drawingml/2006/table">
@@ -35910,7 +35932,7 @@
                           <a:ea typeface="Noto Sans TC"/>
                           <a:cs typeface="Noto Sans TC"/>
                         </a:rPr>
-                        <a:t>不用模型的地板：候選存在時就算得出的數字</a:t>
+                        <a:t>弱地板：候選本來就是靠「差異大」挑的，再排一次沒有資訊</a:t>
                       </a:r>
                     </a:p>
                   </a:txBody>
@@ -35936,7 +35958,7 @@
                           <a:ea typeface="Noto Sans TC"/>
                           <a:cs typeface="Noto Sans TC"/>
                         </a:rPr>
-                        <a:t>ResNet-18，三通道（樣板／待測／差異）</a:t>
+                        <a:t>幾何特徵 30 個 + 梯度提升樹</a:t>
                       </a:r>
                     </a:p>
                   </a:txBody>
@@ -35960,7 +35982,7 @@
                           <a:ea typeface="Noto Sans TC"/>
                           <a:cs typeface="Noto Sans TC"/>
                         </a:rPr>
-                        <a:t>52.8%</a:t>
+                        <a:t>16.70%</a:t>
                       </a:r>
                     </a:p>
                   </a:txBody>
@@ -35984,7 +36006,7 @@
                           <a:ea typeface="Noto Sans TC"/>
                           <a:cs typeface="Noto Sans TC"/>
                         </a:rPr>
-                        <a:t>主線；42.7 MB、11.2M 參數、CPU 2.5 ms</a:t>
+                        <a:t>真地板：形狀看得見。三個 seed 15.94–21.28%</a:t>
                       </a:r>
                     </a:p>
                   </a:txBody>
@@ -36010,7 +36032,7 @@
                           <a:ea typeface="Noto Sans TC"/>
                           <a:cs typeface="Noto Sans TC"/>
                         </a:rPr>
-                        <a:t>同一個 ResNet-18，隨機初始化</a:t>
+                        <a:t>ResNet-18，三通道（樣板／待測／差異）</a:t>
                       </a:r>
                     </a:p>
                   </a:txBody>
@@ -36034,7 +36056,7 @@
                           <a:ea typeface="Noto Sans TC"/>
                           <a:cs typeface="Noto Sans TC"/>
                         </a:rPr>
-                        <a:t>42.32%</a:t>
+                        <a:t>52.79%</a:t>
                       </a:r>
                     </a:p>
                   </a:txBody>
@@ -36058,7 +36080,7 @@
                           <a:ea typeface="Noto Sans TC"/>
                           <a:cs typeface="Noto Sans TC"/>
                         </a:rPr>
-                        <a:t>同一份切分內配對、三個 seed 全同方向；免費的 ImageNet 起點值 10 分</a:t>
+                        <a:t>主線；42.7 MB、11.2M 參數、CPU 2.5 ms</a:t>
                       </a:r>
                     </a:p>
                   </a:txBody>
@@ -36084,7 +36106,7 @@
                           <a:ea typeface="Noto Sans TC"/>
                           <a:cs typeface="Noto Sans TC"/>
                         </a:rPr>
-                        <a:t>同一個 ResNet-18，沒有樣板通道（偵測器 crop）</a:t>
+                        <a:t>同一個 ResNet-18，隨機初始化</a:t>
                       </a:r>
                     </a:p>
                   </a:txBody>
@@ -36108,7 +36130,7 @@
                           <a:ea typeface="Noto Sans TC"/>
                           <a:cs typeface="Noto Sans TC"/>
                         </a:rPr>
-                        <a:t>2.8%</a:t>
+                        <a:t>42.32%</a:t>
                       </a:r>
                     </a:p>
                   </a:txBody>
@@ -36132,7 +36154,7 @@
                           <a:ea typeface="Noto Sans TC"/>
                           <a:cs typeface="Noto Sans TC"/>
                         </a:rPr>
-                        <a:t>外觀本身分不開真假；樣板通道是必要不是方便</a:t>
+                        <a:t>同一份切分內配對、三個 seed 全同方向；免費的 ImageNet 起點值 10 分</a:t>
                       </a:r>
                     </a:p>
                   </a:txBody>
@@ -36158,7 +36180,7 @@
                           <a:ea typeface="Noto Sans TC"/>
                           <a:cs typeface="Noto Sans TC"/>
                         </a:rPr>
-                        <a:t>YOLO26n 的 confidence 直接排序</a:t>
+                        <a:t>同一個 ResNet-18，沒有樣板通道（偵測器 crop）</a:t>
                       </a:r>
                     </a:p>
                   </a:txBody>
@@ -36182,7 +36204,7 @@
                           <a:ea typeface="Noto Sans TC"/>
                           <a:cs typeface="Noto Sans TC"/>
                         </a:rPr>
-                        <a:t>1.2%</a:t>
+                        <a:t>2.8%</a:t>
                       </a:r>
                     </a:p>
                   </a:txBody>
@@ -36206,7 +36228,7 @@
                           <a:ea typeface="Noto Sans TC"/>
                           <a:cs typeface="Noto Sans TC"/>
                         </a:rPr>
-                        <a:t>偵測器的信心是「這裡有東西」的分數，不是 P(false call)</a:t>
+                        <a:t>外觀本身分不開真假；樣板通道是必要不是方便</a:t>
                       </a:r>
                     </a:p>
                   </a:txBody>
@@ -36217,6 +36239,80 @@
                   </a:tcPr>
                 </a:tc>
               </a:tr>
+              <a:tr h="457200">
+                <a:tc>
+                  <a:txBody>
+                    <a:bodyPr/>
+                    <a:lstStyle/>
+                    <a:p>
+                      <a:r>
+                        <a:rPr sz="1300" b="0">
+                          <a:solidFill>
+                            <a:srgbClr val="E8E6E1"/>
+                          </a:solidFill>
+                          <a:latin typeface="Noto Sans TC"/>
+                          <a:ea typeface="Noto Sans TC"/>
+                          <a:cs typeface="Noto Sans TC"/>
+                        </a:rPr>
+                        <a:t>YOLO26n 的 confidence 直接排序</a:t>
+                      </a:r>
+                    </a:p>
+                  </a:txBody>
+                  <a:tcPr marT="36576" marB="36576">
+                    <a:solidFill>
+                      <a:srgbClr val="15171A"/>
+                    </a:solidFill>
+                  </a:tcPr>
+                </a:tc>
+                <a:tc>
+                  <a:txBody>
+                    <a:bodyPr/>
+                    <a:lstStyle/>
+                    <a:p>
+                      <a:r>
+                        <a:rPr sz="1300" b="0">
+                          <a:solidFill>
+                            <a:srgbClr val="E8E6E1"/>
+                          </a:solidFill>
+                          <a:latin typeface="Noto Sans TC"/>
+                          <a:ea typeface="Noto Sans TC"/>
+                          <a:cs typeface="Noto Sans TC"/>
+                        </a:rPr>
+                        <a:t>1.2%</a:t>
+                      </a:r>
+                    </a:p>
+                  </a:txBody>
+                  <a:tcPr marT="36576" marB="36576">
+                    <a:solidFill>
+                      <a:srgbClr val="15171A"/>
+                    </a:solidFill>
+                  </a:tcPr>
+                </a:tc>
+                <a:tc>
+                  <a:txBody>
+                    <a:bodyPr/>
+                    <a:lstStyle/>
+                    <a:p>
+                      <a:r>
+                        <a:rPr sz="1300" b="0">
+                          <a:solidFill>
+                            <a:srgbClr val="E8E6E1"/>
+                          </a:solidFill>
+                          <a:latin typeface="Noto Sans TC"/>
+                          <a:ea typeface="Noto Sans TC"/>
+                          <a:cs typeface="Noto Sans TC"/>
+                        </a:rPr>
+                        <a:t>偵測器的信心是「這裡有東西」的分數，不是 P(false call)</a:t>
+                      </a:r>
+                    </a:p>
+                  </a:txBody>
+                  <a:tcPr marT="36576" marB="36576">
+                    <a:solidFill>
+                      <a:srgbClr val="15171A"/>
+                    </a:solidFill>
+                  </a:tcPr>
+                </a:tc>
+              </a:tr>
             </a:tbl>
           </a:graphicData>
         </a:graphic>
@@ -36229,8 +36325,8 @@
         </p:nvSpPr>
         <p:spPr>
           <a:xfrm>
-            <a:off x="548640" y="4251960"/>
-            <a:ext cx="11064240" cy="2057400"/>
+            <a:off x="548640" y="4709160"/>
+            <a:ext cx="11064240" cy="1600200"/>
           </a:xfrm>
           <a:prstGeom prst="rect">
             <a:avLst/>
@@ -36260,6 +36356,17 @@
               <a:t>• </a:t>
             </a:r>
             <a:r>
+              <a:rPr sz="1400" b="1">
+                <a:solidFill>
+                  <a:srgbClr val="6FC7CF"/>
+                </a:solidFill>
+                <a:latin typeface="Noto Sans TC"/>
+                <a:ea typeface="Noto Sans TC"/>
+                <a:cs typeface="Noto Sans TC"/>
+              </a:rPr>
+              <a:t>地板換了，倍率就從 40 倍變 3.1 倍</a:t>
+            </a:r>
+            <a:r>
               <a:rPr sz="1400" b="0">
                 <a:solidFill>
                   <a:srgbClr val="E8E6E1"/>
@@ -36268,7 +36375,7 @@
                 <a:ea typeface="Noto Sans TC"/>
                 <a:cs typeface="Noto Sans TC"/>
               </a:rPr>
-              <a:t>模型比地板高約 </a:t>
+              <a:t>——</a:t>
             </a:r>
             <a:r>
               <a:rPr sz="1400" b="1">
@@ -36279,7 +36386,7 @@
                 <a:ea typeface="Noto Sans TC"/>
                 <a:cs typeface="Noto Sans TC"/>
               </a:rPr>
-              <a:t>40</a:t>
+              <a:t>1.3%</a:t>
             </a:r>
             <a:r>
               <a:rPr sz="1400" b="0">
@@ -36290,29 +36397,7 @@
                 <a:ea typeface="Noto Sans TC"/>
                 <a:cs typeface="Noto Sans TC"/>
               </a:rPr>
-              <a:t> 倍，這是「模型有學到東西」的證據；沒有地板，</a:t>
-            </a:r>
-            <a:r>
-              <a:rPr sz="1400" b="1">
-                <a:solidFill>
-                  <a:srgbClr val="6FC7CF"/>
-                </a:solidFill>
-                <a:latin typeface="Noto Sans TC"/>
-                <a:ea typeface="Noto Sans TC"/>
-                <a:cs typeface="Noto Sans TC"/>
-              </a:rPr>
-              <a:t>52.8%</a:t>
-            </a:r>
-            <a:r>
-              <a:rPr sz="1400" b="0">
-                <a:solidFill>
-                  <a:srgbClr val="E8E6E1"/>
-                </a:solidFill>
-                <a:latin typeface="Noto Sans TC"/>
-                <a:ea typeface="Noto Sans TC"/>
-                <a:cs typeface="Noto Sans TC"/>
-              </a:rPr>
-              <a:t> 只是一個量，不是證據</a:t>
+              <a:t> 是稻草人，因為它排序用的正是候選被挑出來的那個量；真正該比的是看得見形狀的那個</a:t>
             </a:r>
           </a:p>
           <a:p>

</xml_diff>

<commit_message>
Close-out: the test count, the deck's vocabulary and video link, the interview deck
1,462 tests collect now (1,437 without the dataset) where the READMEs and
CLAUDE.md still said 1,442 and 1,417. The journey deck said 黃金樣板 on three
slides after the station and the demo had moved to "golden image", and its
video link still pointed at the 08-28 release; deck_content.py is corrected
and the html, pptx and study guide rebuilt from it. The interview deck that
lives in docs/deck is a personal file and is now ignored rather than left
untracked.

Co-Authored-By: Claude Fable 5.1 <noreply@anthropic.com>
</commit_message>
<xml_diff>
--- a/docs/deck/aoi-agent-journey.zh-TW.pptx
+++ b/docs/deck/aoi-agent-journey.zh-TW.pptx
@@ -2710,7 +2710,7 @@
           </a:p>
           <a:p>
             <a:r>
-              <a:t>• 三張圖：黃金樣板、待測 PCB、差異圖，紅框是 AOI 標的位置</a:t>
+              <a:t>• 三張圖：golden image、待測 PCB、差異圖，紅框是 AOI 標的位置</a:t>
             </a:r>
           </a:p>
           <a:p>
@@ -13476,7 +13476,7 @@
                 <a:ea typeface="Noto Sans TC"/>
                 <a:cs typeface="Noto Sans TC"/>
               </a:rPr>
-              <a:t>當時要回答的問題是：SMT 的錫膏照片沒有黃金樣板，相減不可能，偵測器是唯一可能的前端——它的 confidence 能不能當 P(false call) 用來排序？我在 PCB-AoI 上訓 YOLO</a:t>
+              <a:t>當時要回答的問題是：SMT 的錫膏照片沒有 golden image，相減不可能，偵測器是唯一可能的前端——它的 confidence 能不能當 P(false call) 用來排序？我在 PCB-AoI 上訓 YOLO</a:t>
             </a:r>
             <a:r>
               <a:rPr sz="1500" b="1">
@@ -30930,7 +30930,7 @@
                 <a:ea typeface="Noto Sans TC"/>
                 <a:cs typeface="Noto Sans TC"/>
               </a:rPr>
-              <a:t>影片：https://github.com/lin891020/aoi-agent/releases/tag/demo-2026-08-28</a:t>
+              <a:t>影片：https://github.com/lin891020/aoi-agent/releases/tag/demo-2026-09-07</a:t>
             </a:r>
           </a:p>
         </p:txBody>
@@ -46903,7 +46903,7 @@
         <p:spPr>
           <a:xfrm>
             <a:off x="457200" y="3227832"/>
-            <a:ext cx="1325880" cy="640080"/>
+            <a:ext cx="1325880" cy="923544"/>
           </a:xfrm>
           <a:prstGeom prst="rect">
             <a:avLst/>
@@ -46944,7 +46944,7 @@
         <p:spPr>
           <a:xfrm>
             <a:off x="1828800" y="3227832"/>
-            <a:ext cx="9875520" cy="640080"/>
+            <a:ext cx="9875520" cy="923544"/>
           </a:xfrm>
           <a:prstGeom prst="rect">
             <a:avLst/>
@@ -46971,7 +46971,7 @@
                 <a:ea typeface="Noto Sans TC"/>
                 <a:cs typeface="Noto Sans TC"/>
               </a:rPr>
-              <a:t>DeepPCB 每片都有黃金樣板、影像已二值化。gate_check.py 是 S</a:t>
+              <a:t>DeepPCB 每片都有 golden image、影像已二值化。gate_check.py 是 S</a:t>
             </a:r>
             <a:r>
               <a:rPr sz="1500" b="1">
@@ -47028,7 +47028,7 @@
         </p:nvSpPr>
         <p:spPr>
           <a:xfrm>
-            <a:off x="457200" y="3995928"/>
+            <a:off x="457200" y="4279392"/>
             <a:ext cx="1325880" cy="356616"/>
           </a:xfrm>
           <a:prstGeom prst="rect">
@@ -47069,7 +47069,7 @@
         </p:nvSpPr>
         <p:spPr>
           <a:xfrm>
-            <a:off x="1828800" y="3995928"/>
+            <a:off x="1828800" y="4279392"/>
             <a:ext cx="9875520" cy="356616"/>
           </a:xfrm>
           <a:prstGeom prst="rect">
@@ -47154,7 +47154,7 @@
         </p:nvSpPr>
         <p:spPr>
           <a:xfrm>
-            <a:off x="320040" y="4443984"/>
+            <a:off x="320040" y="4727448"/>
             <a:ext cx="11521440" cy="713232"/>
           </a:xfrm>
           <a:prstGeom prst="rect">
@@ -47198,7 +47198,7 @@
         </p:nvSpPr>
         <p:spPr>
           <a:xfrm>
-            <a:off x="457200" y="4480560"/>
+            <a:off x="457200" y="4764024"/>
             <a:ext cx="1325880" cy="640080"/>
           </a:xfrm>
           <a:prstGeom prst="rect">
@@ -47239,7 +47239,7 @@
         </p:nvSpPr>
         <p:spPr>
           <a:xfrm>
-            <a:off x="1828800" y="4480560"/>
+            <a:off x="1828800" y="4764024"/>
             <a:ext cx="9875520" cy="640080"/>
           </a:xfrm>
           <a:prstGeom prst="rect">
@@ -47346,7 +47346,7 @@
         </p:nvSpPr>
         <p:spPr>
           <a:xfrm>
-            <a:off x="320040" y="5212080"/>
+            <a:off x="320040" y="5495544"/>
             <a:ext cx="11521440" cy="429768"/>
           </a:xfrm>
           <a:prstGeom prst="rect">
@@ -47390,7 +47390,7 @@
         </p:nvSpPr>
         <p:spPr>
           <a:xfrm>
-            <a:off x="457200" y="5248656"/>
+            <a:off x="457200" y="5532120"/>
             <a:ext cx="1325880" cy="356616"/>
           </a:xfrm>
           <a:prstGeom prst="rect">
@@ -47431,7 +47431,7 @@
         </p:nvSpPr>
         <p:spPr>
           <a:xfrm>
-            <a:off x="1828800" y="5248656"/>
+            <a:off x="1828800" y="5532120"/>
             <a:ext cx="9875520" cy="356616"/>
           </a:xfrm>
           <a:prstGeom prst="rect">

</xml_diff>

<commit_message>
The deck reads the per-class escape at the deployed threshold, dated either way
Two slides still quoted short at 1.55%, 3.1x the budget, as the standing
figure. That is the 0.961 oracle's reading, superseded on 2026-08-31 when
the threshold moved to 0.912: there short escapes at 1.77% and open at
1.16% against 0.66%. The same sentence was corrected in README.zh-TW.md and
CLAUDE.md on 2026-09-08; the deck was the last place it stood undated. Both
slides now state the deployed reading and keep the old one beside its date,
and the study guide and slides are rebuilt from the content file.

Co-Authored-By: Claude Fable 5.1 <noreply@anthropic.com>
</commit_message>
<xml_diff>
--- a/docs/deck/aoi-agent-journey.zh-TW.pptx
+++ b/docs/deck/aoi-agent-journey.zh-TW.pptx
@@ -3979,7 +3979,7 @@
           </a:p>
           <a:p>
             <a:r>
-              <a:t>• 但它漏掉的 short 是 1.55%，預算的 3.1 倍；它放掉的瑕疵分數是 0.00007–0.00589，留下的中位數 1.000——兩堆不重疊，是有信心的錯</a:t>
+              <a:t>• 但它漏掉的 short，在出貨門檻 0.912 下是 1.77%、open 1.16%（08-31 之前讀在 0.961 那個點：short 1.55%、預算的 3.1 倍）；它放掉的瑕疵分數是 0.00007–0.00589，留下的中位數 1.000——兩堆不重疊，是有信心的錯</a:t>
             </a:r>
           </a:p>
           <a:p>
@@ -4000,7 +4000,7 @@
           </a:p>
           <a:p>
             <a:r>
-              <a:t>講稿 2. 左邊有樣板的線：複判器的分數本來就在回答「是不是誤報」，所以拿它排序排掉了 52.8% 的人工，尺是對的。可是它漏掉的 short 是預算的三倍，而且它放掉那些瑕疵的時候分數是 0.00007 到 0.00589，留下的中位數是 1.000——兩堆完全不重疊。</a:t>
+              <a:t>講稿 2. 左邊有樣板的線：複判器的分數本來就在回答「是不是誤報」，所以拿它排序排掉了 52.8% 的人工，尺是對的。可是它漏掉的 short 在 0.961 那個點是預算的三倍，出貨門檻下是 1.77%，而且它放掉那些瑕疵的時候分數是 0.00007 到 0.00589，留下的中位數是 1.000——兩堆完全不重疊。</a:t>
             </a:r>
           </a:p>
           <a:p>
@@ -38399,7 +38399,7 @@
                 <a:ea typeface="Noto Sans TC"/>
                 <a:cs typeface="Noto Sans TC"/>
               </a:rPr>
-              <a:t>電測：關掉 short 那 </a:t>
+              <a:t>電測：關掉 short、open 那 </a:t>
             </a:r>
             <a:r>
               <a:rPr sz="1800" b="1">
@@ -38410,7 +38410,7 @@
                 <a:ea typeface="Noto Sans TC"/>
                 <a:cs typeface="Noto Sans TC"/>
               </a:rPr>
-              <a:t>1.55%</a:t>
+              <a:t>1.77%</a:t>
             </a:r>
             <a:r>
               <a:rPr sz="1800" b="0">
@@ -38421,7 +38421,51 @@
                 <a:ea typeface="Noto Sans TC"/>
                 <a:cs typeface="Noto Sans TC"/>
               </a:rPr>
-              <a:t> 漏網的唯一方法，不在這個系統裡，WI-</a:t>
+              <a:t>、</a:t>
+            </a:r>
+            <a:r>
+              <a:rPr sz="1800" b="1">
+                <a:solidFill>
+                  <a:srgbClr val="6FC7CF"/>
+                </a:solidFill>
+                <a:latin typeface="Noto Sans TC"/>
+                <a:ea typeface="Noto Sans TC"/>
+                <a:cs typeface="Noto Sans TC"/>
+              </a:rPr>
+              <a:t>1.16%</a:t>
+            </a:r>
+            <a:r>
+              <a:rPr sz="1800" b="0">
+                <a:solidFill>
+                  <a:srgbClr val="E8E6E1"/>
+                </a:solidFill>
+                <a:latin typeface="Noto Sans TC"/>
+                <a:ea typeface="Noto Sans TC"/>
+                <a:cs typeface="Noto Sans TC"/>
+              </a:rPr>
+              <a:t> 漏網（出貨門檻 </a:t>
+            </a:r>
+            <a:r>
+              <a:rPr sz="1800" b="1">
+                <a:solidFill>
+                  <a:srgbClr val="6FC7CF"/>
+                </a:solidFill>
+                <a:latin typeface="Noto Sans TC"/>
+                <a:ea typeface="Noto Sans TC"/>
+                <a:cs typeface="Noto Sans TC"/>
+              </a:rPr>
+              <a:t>0.912</a:t>
+            </a:r>
+            <a:r>
+              <a:rPr sz="1800" b="0">
+                <a:solidFill>
+                  <a:srgbClr val="E8E6E1"/>
+                </a:solidFill>
+                <a:latin typeface="Noto Sans TC"/>
+                <a:ea typeface="Noto Sans TC"/>
+                <a:cs typeface="Noto Sans TC"/>
+              </a:rPr>
+              <a:t>）的唯一方法，不在這個系統裡，WI-</a:t>
             </a:r>
             <a:r>
               <a:rPr sz="1800" b="1">

</xml_diff>